<commit_message>
Refine ADIB presentation design
Co-authored-by: Amr Essam <amressam93@users.noreply.github.com>
</commit_message>
<xml_diff>
--- a/presentation/ADIB_Cards_Presentation.pptx
+++ b/presentation/ADIB_Cards_Presentation.pptx
@@ -3089,7 +3089,7 @@
     <p:bg>
       <p:bgPr>
         <a:solidFill>
-          <a:srgbClr val="F6F9FC"/>
+          <a:srgbClr val="FFFFFF"/>
         </a:solidFill>
         <a:effectLst/>
       </p:bgPr>
@@ -3110,52 +3110,7 @@
         <p:spPr>
           <a:xfrm>
             <a:off x="0" y="0"/>
-            <a:ext cx="4663440" cy="6858000"/>
-          </a:xfrm>
-          <a:prstGeom prst="rect">
-            <a:avLst/>
-          </a:prstGeom>
-          <a:solidFill>
-            <a:srgbClr val="FFFFFF"/>
-          </a:solidFill>
-          <a:ln>
-            <a:solidFill>
-              <a:srgbClr val="FFFFFF"/>
-            </a:solidFill>
-          </a:ln>
-        </p:spPr>
-        <p:style>
-          <a:lnRef idx="1">
-            <a:schemeClr val="accent1"/>
-          </a:lnRef>
-          <a:fillRef idx="3">
-            <a:schemeClr val="accent1"/>
-          </a:fillRef>
-          <a:effectRef idx="2">
-            <a:schemeClr val="accent1"/>
-          </a:effectRef>
-          <a:fontRef idx="minor">
-            <a:schemeClr val="lt1"/>
-          </a:fontRef>
-        </p:style>
-        <p:txBody>
-          <a:bodyPr rtlCol="0" anchor="ctr"/>
-          <a:lstStyle/>
-          <a:p>
-            <a:pPr algn="ctr"/>
-          </a:p>
-        </p:txBody>
-      </p:sp>
-      <p:sp>
-        <p:nvSpPr>
-          <p:cNvPr id="3" name="Rectangle 2"/>
-          <p:cNvSpPr/>
-          <p:nvPr/>
-        </p:nvSpPr>
-        <p:spPr>
-          <a:xfrm>
-            <a:off x="0" y="0"/>
-            <a:ext cx="146304" cy="6858000"/>
+            <a:ext cx="164592" cy="6858000"/>
           </a:xfrm>
           <a:prstGeom prst="rect">
             <a:avLst/>
@@ -3193,24 +3148,24 @@
       </p:sp>
       <p:sp>
         <p:nvSpPr>
-          <p:cNvPr id="4" name="Rounded Rectangle 3"/>
+          <p:cNvPr id="3" name="Rounded Rectangle 2"/>
           <p:cNvSpPr/>
           <p:nvPr/>
         </p:nvSpPr>
         <p:spPr>
           <a:xfrm>
-            <a:off x="5486400" y="640080"/>
-            <a:ext cx="6126480" cy="5532120"/>
+            <a:off x="5669280" y="548640"/>
+            <a:ext cx="5897880" cy="5715000"/>
           </a:xfrm>
           <a:prstGeom prst="roundRect">
             <a:avLst/>
           </a:prstGeom>
           <a:solidFill>
-            <a:srgbClr val="E8F2FA"/>
+            <a:srgbClr val="E8F4FB"/>
           </a:solidFill>
           <a:ln>
             <a:solidFill>
-              <a:srgbClr val="E8F2FA"/>
+              <a:srgbClr val="E8F4FB"/>
             </a:solidFill>
           </a:ln>
         </p:spPr>
@@ -3238,7 +3193,7 @@
       </p:sp>
       <p:pic>
         <p:nvPicPr>
-          <p:cNvPr id="5" name="Picture 4" descr="adib_logo_transparent.png"/>
+          <p:cNvPr id="4" name="Picture 3" descr="adib_logo_transparent.png"/>
           <p:cNvPicPr>
             <a:picLocks noChangeAspect="1"/>
           </p:cNvPicPr>
@@ -3252,8 +3207,8 @@
         </p:blipFill>
         <p:spPr>
           <a:xfrm>
-            <a:off x="822960" y="713232"/>
-            <a:ext cx="1051560" cy="1051560"/>
+            <a:off x="777240" y="713232"/>
+            <a:ext cx="512064" cy="512064"/>
           </a:xfrm>
           <a:prstGeom prst="rect">
             <a:avLst/>
@@ -3262,14 +3217,14 @@
       </p:pic>
       <p:sp>
         <p:nvSpPr>
-          <p:cNvPr id="6" name="TextBox 5"/>
+          <p:cNvPr id="5" name="TextBox 4"/>
           <p:cNvSpPr txBox="1"/>
           <p:nvPr/>
         </p:nvSpPr>
         <p:spPr>
           <a:xfrm>
-            <a:off x="1975104" y="749808"/>
-            <a:ext cx="1920240" cy="530352"/>
+            <a:off x="1362456" y="786384"/>
+            <a:ext cx="1097280" cy="256032"/>
           </a:xfrm>
           <a:prstGeom prst="rect">
             <a:avLst/>
@@ -3284,7 +3239,7 @@
           <a:p>
             <a:pPr algn="l"/>
             <a:r>
-              <a:rPr sz="3800" b="1">
+              <a:rPr sz="2200" b="1">
                 <a:solidFill>
                   <a:srgbClr val="003E7E"/>
                 </a:solidFill>
@@ -3297,14 +3252,14 @@
       </p:sp>
       <p:sp>
         <p:nvSpPr>
-          <p:cNvPr id="7" name="TextBox 6"/>
+          <p:cNvPr id="6" name="TextBox 5"/>
           <p:cNvSpPr txBox="1"/>
           <p:nvPr/>
         </p:nvSpPr>
         <p:spPr>
           <a:xfrm>
-            <a:off x="1993392" y="1243584"/>
-            <a:ext cx="2240280" cy="274320"/>
+            <a:off x="786384" y="1417320"/>
+            <a:ext cx="2926080" cy="256032"/>
           </a:xfrm>
           <a:prstGeom prst="rect">
             <a:avLst/>
@@ -3332,14 +3287,14 @@
       </p:sp>
       <p:sp>
         <p:nvSpPr>
-          <p:cNvPr id="8" name="TextBox 7"/>
+          <p:cNvPr id="7" name="TextBox 6"/>
           <p:cNvSpPr txBox="1"/>
           <p:nvPr/>
         </p:nvSpPr>
         <p:spPr>
           <a:xfrm>
-            <a:off x="822960" y="2011680"/>
-            <a:ext cx="3474720" cy="566928"/>
+            <a:off x="777240" y="2148840"/>
+            <a:ext cx="4069080" cy="658368"/>
           </a:xfrm>
           <a:prstGeom prst="rect">
             <a:avLst/>
@@ -3354,7 +3309,7 @@
           <a:p>
             <a:pPr algn="l"/>
             <a:r>
-              <a:rPr sz="3500" b="1">
+              <a:rPr sz="4200" b="1">
                 <a:solidFill>
                   <a:srgbClr val="1A2636"/>
                 </a:solidFill>
@@ -3367,14 +3322,14 @@
       </p:sp>
       <p:sp>
         <p:nvSpPr>
-          <p:cNvPr id="9" name="TextBox 8"/>
+          <p:cNvPr id="8" name="TextBox 7"/>
           <p:cNvSpPr txBox="1"/>
           <p:nvPr/>
         </p:nvSpPr>
         <p:spPr>
           <a:xfrm>
-            <a:off x="859536" y="2651760"/>
-            <a:ext cx="2926080" cy="320040"/>
+            <a:off x="804672" y="2880360"/>
+            <a:ext cx="3200400" cy="320040"/>
           </a:xfrm>
           <a:prstGeom prst="rect">
             <a:avLst/>
@@ -3402,85 +3357,14 @@
       </p:sp>
       <p:sp>
         <p:nvSpPr>
-          <p:cNvPr id="10" name="TextBox 9"/>
+          <p:cNvPr id="9" name="TextBox 8"/>
           <p:cNvSpPr txBox="1"/>
           <p:nvPr/>
         </p:nvSpPr>
         <p:spPr>
           <a:xfrm>
-            <a:off x="868680" y="3337560"/>
-            <a:ext cx="2743200" cy="1188720"/>
-          </a:xfrm>
-          <a:prstGeom prst="rect">
-            <a:avLst/>
-          </a:prstGeom>
-          <a:noFill/>
-        </p:spPr>
-        <p:txBody>
-          <a:bodyPr wrap="none" rIns="45720" tIns="27432" bIns="27432">
-            <a:spAutoFit/>
-          </a:bodyPr>
-          <a:lstStyle/>
-          <a:p>
-            <a:pPr>
-              <a:spcAft>
-                <a:spcPts val="800"/>
-              </a:spcAft>
-              <a:defRPr sz="1800">
-                <a:solidFill>
-                  <a:srgbClr val="5C6874"/>
-                </a:solidFill>
-                <a:latin typeface="Arial"/>
-              </a:defRPr>
-            </a:pPr>
-            <a:r>
-              <a:t>Cash Back</a:t>
-            </a:r>
-          </a:p>
-          <a:p>
-            <a:pPr>
-              <a:spcAft>
-                <a:spcPts val="800"/>
-              </a:spcAft>
-              <a:defRPr sz="1800">
-                <a:solidFill>
-                  <a:srgbClr val="5C6874"/>
-                </a:solidFill>
-                <a:latin typeface="Arial"/>
-              </a:defRPr>
-            </a:pPr>
-            <a:r>
-              <a:t>Titanium</a:t>
-            </a:r>
-          </a:p>
-          <a:p>
-            <a:pPr>
-              <a:spcAft>
-                <a:spcPts val="800"/>
-              </a:spcAft>
-              <a:defRPr sz="1800">
-                <a:solidFill>
-                  <a:srgbClr val="5C6874"/>
-                </a:solidFill>
-                <a:latin typeface="Arial"/>
-              </a:defRPr>
-            </a:pPr>
-            <a:r>
-              <a:t>Platinum</a:t>
-            </a:r>
-          </a:p>
-        </p:txBody>
-      </p:sp>
-      <p:sp>
-        <p:nvSpPr>
-          <p:cNvPr id="11" name="TextBox 10"/>
-          <p:cNvSpPr txBox="1"/>
-          <p:nvPr/>
-        </p:nvSpPr>
-        <p:spPr>
-          <a:xfrm>
-            <a:off x="868680" y="5806440"/>
-            <a:ext cx="3429000" cy="411480"/>
+            <a:off x="822960" y="3584448"/>
+            <a:ext cx="4069080" cy="777240"/>
           </a:xfrm>
           <a:prstGeom prst="rect">
             <a:avLst/>
@@ -3495,13 +3379,93 @@
           <a:p>
             <a:pPr algn="l"/>
             <a:r>
-              <a:rPr sz="1200" b="0">
+              <a:rPr sz="1600" b="0">
                 <a:solidFill>
                   <a:srgbClr val="5C6874"/>
                 </a:solidFill>
                 <a:latin typeface="Arial"/>
               </a:rPr>
-              <a:t>Clear design. Readable slides. Product-focused visuals.</a:t>
+              <a:t>A clean introduction to ADIB card products, designed for quick reading and strong visual impact.</a:t>
+            </a:r>
+          </a:p>
+        </p:txBody>
+      </p:sp>
+      <p:sp>
+        <p:nvSpPr>
+          <p:cNvPr id="10" name="Rounded Rectangle 9"/>
+          <p:cNvSpPr/>
+          <p:nvPr/>
+        </p:nvSpPr>
+        <p:spPr>
+          <a:xfrm>
+            <a:off x="822960" y="4956048"/>
+            <a:ext cx="3337560" cy="621792"/>
+          </a:xfrm>
+          <a:prstGeom prst="roundRect">
+            <a:avLst/>
+          </a:prstGeom>
+          <a:solidFill>
+            <a:srgbClr val="F6F9FC"/>
+          </a:solidFill>
+          <a:ln>
+            <a:solidFill>
+              <a:srgbClr val="DDE7F0"/>
+            </a:solidFill>
+          </a:ln>
+        </p:spPr>
+        <p:style>
+          <a:lnRef idx="1">
+            <a:schemeClr val="accent1"/>
+          </a:lnRef>
+          <a:fillRef idx="3">
+            <a:schemeClr val="accent1"/>
+          </a:fillRef>
+          <a:effectRef idx="2">
+            <a:schemeClr val="accent1"/>
+          </a:effectRef>
+          <a:fontRef idx="minor">
+            <a:schemeClr val="lt1"/>
+          </a:fontRef>
+        </p:style>
+        <p:txBody>
+          <a:bodyPr rtlCol="0" anchor="ctr"/>
+          <a:lstStyle/>
+          <a:p>
+            <a:pPr algn="ctr"/>
+          </a:p>
+        </p:txBody>
+      </p:sp>
+      <p:sp>
+        <p:nvSpPr>
+          <p:cNvPr id="11" name="TextBox 10"/>
+          <p:cNvSpPr txBox="1"/>
+          <p:nvPr/>
+        </p:nvSpPr>
+        <p:spPr>
+          <a:xfrm>
+            <a:off x="1024128" y="5148072"/>
+            <a:ext cx="2926080" cy="182880"/>
+          </a:xfrm>
+          <a:prstGeom prst="rect">
+            <a:avLst/>
+          </a:prstGeom>
+          <a:noFill/>
+        </p:spPr>
+        <p:txBody>
+          <a:bodyPr wrap="none" lIns="0" rIns="0" tIns="0" bIns="0">
+            <a:spAutoFit/>
+          </a:bodyPr>
+          <a:lstStyle/>
+          <a:p>
+            <a:pPr algn="ctr"/>
+            <a:r>
+              <a:rPr sz="1100" b="1">
+                <a:solidFill>
+                  <a:srgbClr val="003E7E"/>
+                </a:solidFill>
+                <a:latin typeface="Arial"/>
+              </a:rPr>
+              <a:t>Cash Back  |  Titanium  |  Platinum</a:t>
             </a:r>
           </a:p>
         </p:txBody>
@@ -3522,8 +3486,8 @@
         </p:blipFill>
         <p:spPr>
           <a:xfrm>
-            <a:off x="5596128" y="1586484"/>
-            <a:ext cx="5669280" cy="3401568"/>
+            <a:off x="5779008" y="1668780"/>
+            <a:ext cx="5486400" cy="3291840"/>
           </a:xfrm>
           <a:prstGeom prst="rect">
             <a:avLst/>
@@ -3538,8 +3502,8 @@
         </p:nvSpPr>
         <p:spPr>
           <a:xfrm>
-            <a:off x="6537960" y="5696712"/>
-            <a:ext cx="4023360" cy="365760"/>
+            <a:off x="6903720" y="5596128"/>
+            <a:ext cx="3291840" cy="292608"/>
           </a:xfrm>
           <a:prstGeom prst="rect">
             <a:avLst/>
@@ -3554,7 +3518,7 @@
           <a:p>
             <a:pPr algn="ctr"/>
             <a:r>
-              <a:rPr sz="1800" b="1">
+              <a:rPr sz="1500" b="1">
                 <a:solidFill>
                   <a:srgbClr val="003E7E"/>
                 </a:solidFill>
@@ -3591,16 +3555,40 @@
         <p:nvPr/>
       </p:nvGrpSpPr>
       <p:grpSpPr/>
-      <p:sp>
-        <p:nvSpPr>
-          <p:cNvPr id="2" name="TextBox 1"/>
+      <p:pic>
+        <p:nvPicPr>
+          <p:cNvPr id="2" name="Picture 1" descr="adib_logo_transparent.png"/>
+          <p:cNvPicPr>
+            <a:picLocks noChangeAspect="1"/>
+          </p:cNvPicPr>
+          <p:nvPr/>
+        </p:nvPicPr>
+        <p:blipFill>
+          <a:blip r:embed="rId2"/>
+          <a:stretch>
+            <a:fillRect/>
+          </a:stretch>
+        </p:blipFill>
+        <p:spPr>
+          <a:xfrm>
+            <a:off x="658368" y="320040"/>
+            <a:ext cx="384048" cy="384048"/>
+          </a:xfrm>
+          <a:prstGeom prst="rect">
+            <a:avLst/>
+          </a:prstGeom>
+        </p:spPr>
+      </p:pic>
+      <p:sp>
+        <p:nvSpPr>
+          <p:cNvPr id="3" name="TextBox 2"/>
           <p:cNvSpPr txBox="1"/>
           <p:nvPr/>
         </p:nvSpPr>
         <p:spPr>
           <a:xfrm>
-            <a:off x="658368" y="384048"/>
-            <a:ext cx="8503920" cy="411480"/>
+            <a:off x="1115568" y="374904"/>
+            <a:ext cx="1097280" cy="256032"/>
           </a:xfrm>
           <a:prstGeom prst="rect">
             <a:avLst/>
@@ -3615,26 +3603,61 @@
           <a:p>
             <a:pPr algn="l"/>
             <a:r>
-              <a:rPr sz="2500" b="1">
+              <a:rPr sz="1600" b="1">
                 <a:solidFill>
                   <a:srgbClr val="003E7E"/>
                 </a:solidFill>
                 <a:latin typeface="Arial"/>
               </a:rPr>
-              <a:t>Cash Back Cards Overview</a:t>
-            </a:r>
-          </a:p>
-        </p:txBody>
-      </p:sp>
-      <p:sp>
-        <p:nvSpPr>
-          <p:cNvPr id="3" name="Rounded Rectangle 2"/>
+              <a:t>ADIB</a:t>
+            </a:r>
+          </a:p>
+        </p:txBody>
+      </p:sp>
+      <p:sp>
+        <p:nvSpPr>
+          <p:cNvPr id="4" name="TextBox 3"/>
+          <p:cNvSpPr txBox="1"/>
+          <p:nvPr/>
+        </p:nvSpPr>
+        <p:spPr>
+          <a:xfrm>
+            <a:off x="658368" y="841248"/>
+            <a:ext cx="8503920" cy="411480"/>
+          </a:xfrm>
+          <a:prstGeom prst="rect">
+            <a:avLst/>
+          </a:prstGeom>
+          <a:noFill/>
+        </p:spPr>
+        <p:txBody>
+          <a:bodyPr wrap="none" lIns="0" rIns="0" tIns="0" bIns="0">
+            <a:spAutoFit/>
+          </a:bodyPr>
+          <a:lstStyle/>
+          <a:p>
+            <a:pPr algn="l"/>
+            <a:r>
+              <a:rPr sz="2500" b="1">
+                <a:solidFill>
+                  <a:srgbClr val="003E7E"/>
+                </a:solidFill>
+                <a:latin typeface="Arial"/>
+              </a:rPr>
+              <a:t>Portfolio at a Glance</a:t>
+            </a:r>
+          </a:p>
+        </p:txBody>
+      </p:sp>
+      <p:sp>
+        <p:nvSpPr>
+          <p:cNvPr id="5" name="Rounded Rectangle 4"/>
           <p:cNvSpPr/>
           <p:nvPr/>
         </p:nvSpPr>
         <p:spPr>
           <a:xfrm>
-            <a:off x="10012680" y="384048"/>
+            <a:off x="10012680" y="502920"/>
             <a:ext cx="1554480" cy="329184"/>
           </a:xfrm>
           <a:prstGeom prst="roundRect">
@@ -3673,13 +3696,13 @@
       </p:sp>
       <p:sp>
         <p:nvSpPr>
-          <p:cNvPr id="4" name="TextBox 3"/>
+          <p:cNvPr id="6" name="TextBox 5"/>
           <p:cNvSpPr txBox="1"/>
           <p:nvPr/>
         </p:nvSpPr>
         <p:spPr>
           <a:xfrm>
-            <a:off x="10158984" y="438912"/>
+            <a:off x="10158984" y="557784"/>
             <a:ext cx="1261872" cy="201168"/>
           </a:xfrm>
           <a:prstGeom prst="rect">
@@ -3708,24 +3731,24 @@
       </p:sp>
       <p:sp>
         <p:nvSpPr>
-          <p:cNvPr id="5" name="Rectangle 4"/>
+          <p:cNvPr id="7" name="Rectangle 6"/>
           <p:cNvSpPr/>
           <p:nvPr/>
         </p:nvSpPr>
         <p:spPr>
           <a:xfrm>
-            <a:off x="658368" y="932688"/>
+            <a:off x="658368" y="1344168"/>
             <a:ext cx="10881360" cy="18288"/>
           </a:xfrm>
           <a:prstGeom prst="rect">
             <a:avLst/>
           </a:prstGeom>
           <a:solidFill>
-            <a:srgbClr val="DBE5EF"/>
+            <a:srgbClr val="DDE7F0"/>
           </a:solidFill>
           <a:ln>
             <a:solidFill>
-              <a:srgbClr val="DBE5EF"/>
+              <a:srgbClr val="DDE7F0"/>
             </a:solidFill>
           </a:ln>
         </p:spPr>
@@ -3751,40 +3774,16 @@
           </a:p>
         </p:txBody>
       </p:sp>
-      <p:pic>
-        <p:nvPicPr>
-          <p:cNvPr id="6" name="Picture 5" descr="cashback_banner.jpg"/>
-          <p:cNvPicPr>
-            <a:picLocks noChangeAspect="1"/>
-          </p:cNvPicPr>
-          <p:nvPr/>
-        </p:nvPicPr>
-        <p:blipFill>
-          <a:blip r:embed="rId2"/>
-          <a:stretch>
-            <a:fillRect/>
-          </a:stretch>
-        </p:blipFill>
-        <p:spPr>
-          <a:xfrm>
-            <a:off x="2247263" y="1207008"/>
-            <a:ext cx="7703570" cy="3310128"/>
-          </a:xfrm>
-          <a:prstGeom prst="rect">
-            <a:avLst/>
-          </a:prstGeom>
-        </p:spPr>
-      </p:pic>
-      <p:sp>
-        <p:nvSpPr>
-          <p:cNvPr id="7" name="Rounded Rectangle 6"/>
+      <p:sp>
+        <p:nvSpPr>
+          <p:cNvPr id="8" name="Rounded Rectangle 7"/>
           <p:cNvSpPr/>
           <p:nvPr/>
         </p:nvSpPr>
         <p:spPr>
           <a:xfrm>
-            <a:off x="658368" y="4800600"/>
-            <a:ext cx="3310128" cy="1143000"/>
+            <a:off x="777240" y="1783080"/>
+            <a:ext cx="3154680" cy="3977639"/>
           </a:xfrm>
           <a:prstGeom prst="roundRect">
             <a:avLst/>
@@ -3794,7 +3793,7 @@
           </a:solidFill>
           <a:ln>
             <a:solidFill>
-              <a:srgbClr val="F6F9FC"/>
+              <a:srgbClr val="DDE7F0"/>
             </a:solidFill>
           </a:ln>
         </p:spPr>
@@ -3822,14 +3821,108 @@
       </p:sp>
       <p:sp>
         <p:nvSpPr>
-          <p:cNvPr id="8" name="Rounded Rectangle 7"/>
+          <p:cNvPr id="9" name="TextBox 8"/>
+          <p:cNvSpPr txBox="1"/>
+          <p:nvPr/>
+        </p:nvSpPr>
+        <p:spPr>
+          <a:xfrm>
+            <a:off x="1005840" y="2029968"/>
+            <a:ext cx="2697480" cy="320040"/>
+          </a:xfrm>
+          <a:prstGeom prst="rect">
+            <a:avLst/>
+          </a:prstGeom>
+          <a:noFill/>
+        </p:spPr>
+        <p:txBody>
+          <a:bodyPr wrap="none" lIns="0" rIns="0" tIns="0" bIns="0">
+            <a:spAutoFit/>
+          </a:bodyPr>
+          <a:lstStyle/>
+          <a:p>
+            <a:pPr algn="ctr"/>
+            <a:r>
+              <a:rPr sz="2200" b="1">
+                <a:solidFill>
+                  <a:srgbClr val="0097D6"/>
+                </a:solidFill>
+                <a:latin typeface="Arial"/>
+              </a:rPr>
+              <a:t>Cash Back</a:t>
+            </a:r>
+          </a:p>
+        </p:txBody>
+      </p:sp>
+      <p:pic>
+        <p:nvPicPr>
+          <p:cNvPr id="10" name="Picture 9" descr="classic_card.png"/>
+          <p:cNvPicPr>
+            <a:picLocks noChangeAspect="1"/>
+          </p:cNvPicPr>
+          <p:nvPr/>
+        </p:nvPicPr>
+        <p:blipFill>
+          <a:blip r:embed="rId3"/>
+          <a:stretch>
+            <a:fillRect/>
+          </a:stretch>
+        </p:blipFill>
+        <p:spPr>
+          <a:xfrm>
+            <a:off x="960120" y="2607095"/>
+            <a:ext cx="2788920" cy="1844977"/>
+          </a:xfrm>
+          <a:prstGeom prst="rect">
+            <a:avLst/>
+          </a:prstGeom>
+        </p:spPr>
+      </p:pic>
+      <p:sp>
+        <p:nvSpPr>
+          <p:cNvPr id="11" name="TextBox 10"/>
+          <p:cNvSpPr txBox="1"/>
+          <p:nvPr/>
+        </p:nvSpPr>
+        <p:spPr>
+          <a:xfrm>
+            <a:off x="1088136" y="4828032"/>
+            <a:ext cx="2487168" cy="237744"/>
+          </a:xfrm>
+          <a:prstGeom prst="rect">
+            <a:avLst/>
+          </a:prstGeom>
+          <a:noFill/>
+        </p:spPr>
+        <p:txBody>
+          <a:bodyPr wrap="none" lIns="0" rIns="0" tIns="0" bIns="0">
+            <a:spAutoFit/>
+          </a:bodyPr>
+          <a:lstStyle/>
+          <a:p>
+            <a:pPr algn="ctr"/>
+            <a:r>
+              <a:rPr sz="1300" b="0">
+                <a:solidFill>
+                  <a:srgbClr val="5C6874"/>
+                </a:solidFill>
+                <a:latin typeface="Arial"/>
+              </a:rPr>
+              <a:t>Everyday rewards</a:t>
+            </a:r>
+          </a:p>
+        </p:txBody>
+      </p:sp>
+      <p:sp>
+        <p:nvSpPr>
+          <p:cNvPr id="12" name="Rounded Rectangle 11"/>
           <p:cNvSpPr/>
           <p:nvPr/>
         </p:nvSpPr>
         <p:spPr>
           <a:xfrm>
-            <a:off x="4443984" y="4800600"/>
-            <a:ext cx="3310128" cy="1143000"/>
+            <a:off x="4507992" y="1783080"/>
+            <a:ext cx="3154680" cy="3977639"/>
           </a:xfrm>
           <a:prstGeom prst="roundRect">
             <a:avLst/>
@@ -3839,7 +3932,7 @@
           </a:solidFill>
           <a:ln>
             <a:solidFill>
-              <a:srgbClr val="F6F9FC"/>
+              <a:srgbClr val="DDE7F0"/>
             </a:solidFill>
           </a:ln>
         </p:spPr>
@@ -3867,14 +3960,108 @@
       </p:sp>
       <p:sp>
         <p:nvSpPr>
-          <p:cNvPr id="9" name="Rounded Rectangle 8"/>
+          <p:cNvPr id="13" name="TextBox 12"/>
+          <p:cNvSpPr txBox="1"/>
+          <p:nvPr/>
+        </p:nvSpPr>
+        <p:spPr>
+          <a:xfrm>
+            <a:off x="4736592" y="2029968"/>
+            <a:ext cx="2697480" cy="320040"/>
+          </a:xfrm>
+          <a:prstGeom prst="rect">
+            <a:avLst/>
+          </a:prstGeom>
+          <a:noFill/>
+        </p:spPr>
+        <p:txBody>
+          <a:bodyPr wrap="none" lIns="0" rIns="0" tIns="0" bIns="0">
+            <a:spAutoFit/>
+          </a:bodyPr>
+          <a:lstStyle/>
+          <a:p>
+            <a:pPr algn="ctr"/>
+            <a:r>
+              <a:rPr sz="2200" b="1">
+                <a:solidFill>
+                  <a:srgbClr val="1A2636"/>
+                </a:solidFill>
+                <a:latin typeface="Arial"/>
+              </a:rPr>
+              <a:t>Titanium</a:t>
+            </a:r>
+          </a:p>
+        </p:txBody>
+      </p:sp>
+      <p:pic>
+        <p:nvPicPr>
+          <p:cNvPr id="14" name="Picture 13" descr="titanium_card.png"/>
+          <p:cNvPicPr>
+            <a:picLocks noChangeAspect="1"/>
+          </p:cNvPicPr>
+          <p:nvPr/>
+        </p:nvPicPr>
+        <p:blipFill>
+          <a:blip r:embed="rId4"/>
+          <a:stretch>
+            <a:fillRect/>
+          </a:stretch>
+        </p:blipFill>
+        <p:spPr>
+          <a:xfrm>
+            <a:off x="4690872" y="2607095"/>
+            <a:ext cx="2788920" cy="1844977"/>
+          </a:xfrm>
+          <a:prstGeom prst="rect">
+            <a:avLst/>
+          </a:prstGeom>
+        </p:spPr>
+      </p:pic>
+      <p:sp>
+        <p:nvSpPr>
+          <p:cNvPr id="15" name="TextBox 14"/>
+          <p:cNvSpPr txBox="1"/>
+          <p:nvPr/>
+        </p:nvSpPr>
+        <p:spPr>
+          <a:xfrm>
+            <a:off x="4818888" y="4828032"/>
+            <a:ext cx="2487168" cy="237744"/>
+          </a:xfrm>
+          <a:prstGeom prst="rect">
+            <a:avLst/>
+          </a:prstGeom>
+          <a:noFill/>
+        </p:spPr>
+        <p:txBody>
+          <a:bodyPr wrap="none" lIns="0" rIns="0" tIns="0" bIns="0">
+            <a:spAutoFit/>
+          </a:bodyPr>
+          <a:lstStyle/>
+          <a:p>
+            <a:pPr algn="ctr"/>
+            <a:r>
+              <a:rPr sz="1300" b="0">
+                <a:solidFill>
+                  <a:srgbClr val="5C6874"/>
+                </a:solidFill>
+                <a:latin typeface="Arial"/>
+              </a:rPr>
+              <a:t>Modern daily banking</a:t>
+            </a:r>
+          </a:p>
+        </p:txBody>
+      </p:sp>
+      <p:sp>
+        <p:nvSpPr>
+          <p:cNvPr id="16" name="Rounded Rectangle 15"/>
           <p:cNvSpPr/>
           <p:nvPr/>
         </p:nvSpPr>
         <p:spPr>
           <a:xfrm>
-            <a:off x="8229600" y="4800600"/>
-            <a:ext cx="3310128" cy="1143000"/>
+            <a:off x="8238744" y="1783080"/>
+            <a:ext cx="3154680" cy="3977639"/>
           </a:xfrm>
           <a:prstGeom prst="roundRect">
             <a:avLst/>
@@ -3884,7 +4071,7 @@
           </a:solidFill>
           <a:ln>
             <a:solidFill>
-              <a:srgbClr val="F6F9FC"/>
+              <a:srgbClr val="DDE7F0"/>
             </a:solidFill>
           </a:ln>
         </p:spPr>
@@ -3912,14 +4099,14 @@
       </p:sp>
       <p:sp>
         <p:nvSpPr>
-          <p:cNvPr id="10" name="TextBox 9"/>
+          <p:cNvPr id="17" name="TextBox 16"/>
           <p:cNvSpPr txBox="1"/>
           <p:nvPr/>
         </p:nvSpPr>
         <p:spPr>
           <a:xfrm>
-            <a:off x="896112" y="4992624"/>
-            <a:ext cx="2743200" cy="256032"/>
+            <a:off x="8467344" y="2029968"/>
+            <a:ext cx="2697480" cy="320040"/>
           </a:xfrm>
           <a:prstGeom prst="rect">
             <a:avLst/>
@@ -3932,29 +4119,53 @@
           </a:bodyPr>
           <a:lstStyle/>
           <a:p>
-            <a:pPr algn="l"/>
-            <a:r>
-              <a:rPr sz="1700" b="1">
-                <a:solidFill>
-                  <a:srgbClr val="003E7E"/>
+            <a:pPr algn="ctr"/>
+            <a:r>
+              <a:rPr sz="2200" b="1">
+                <a:solidFill>
+                  <a:srgbClr val="F2A630"/>
                 </a:solidFill>
                 <a:latin typeface="Arial"/>
               </a:rPr>
-              <a:t>Cashback</a:t>
-            </a:r>
-          </a:p>
-        </p:txBody>
-      </p:sp>
-      <p:sp>
-        <p:nvSpPr>
-          <p:cNvPr id="11" name="TextBox 10"/>
+              <a:t>Platinum</a:t>
+            </a:r>
+          </a:p>
+        </p:txBody>
+      </p:sp>
+      <p:pic>
+        <p:nvPicPr>
+          <p:cNvPr id="18" name="Picture 17" descr="platinum_card.png"/>
+          <p:cNvPicPr>
+            <a:picLocks noChangeAspect="1"/>
+          </p:cNvPicPr>
+          <p:nvPr/>
+        </p:nvPicPr>
+        <p:blipFill>
+          <a:blip r:embed="rId5"/>
+          <a:stretch>
+            <a:fillRect/>
+          </a:stretch>
+        </p:blipFill>
+        <p:spPr>
+          <a:xfrm>
+            <a:off x="8421624" y="2607095"/>
+            <a:ext cx="2788920" cy="1844977"/>
+          </a:xfrm>
+          <a:prstGeom prst="rect">
+            <a:avLst/>
+          </a:prstGeom>
+        </p:spPr>
+      </p:pic>
+      <p:sp>
+        <p:nvSpPr>
+          <p:cNvPr id="19" name="TextBox 18"/>
           <p:cNvSpPr txBox="1"/>
           <p:nvPr/>
         </p:nvSpPr>
         <p:spPr>
           <a:xfrm>
-            <a:off x="896112" y="5376672"/>
-            <a:ext cx="2560320" cy="274320"/>
+            <a:off x="8549640" y="4828032"/>
+            <a:ext cx="2487168" cy="237744"/>
           </a:xfrm>
           <a:prstGeom prst="rect">
             <a:avLst/>
@@ -3967,29 +4178,74 @@
           </a:bodyPr>
           <a:lstStyle/>
           <a:p>
-            <a:pPr algn="l"/>
-            <a:r>
-              <a:rPr sz="1200" b="0">
+            <a:pPr algn="ctr"/>
+            <a:r>
+              <a:rPr sz="1300" b="0">
                 <a:solidFill>
                   <a:srgbClr val="5C6874"/>
                 </a:solidFill>
                 <a:latin typeface="Arial"/>
               </a:rPr>
-              <a:t>Rewards on card purchases</a:t>
-            </a:r>
-          </a:p>
-        </p:txBody>
-      </p:sp>
-      <p:sp>
-        <p:nvSpPr>
-          <p:cNvPr id="12" name="TextBox 11"/>
+              <a:t>Premium positioning</a:t>
+            </a:r>
+          </a:p>
+        </p:txBody>
+      </p:sp>
+      <p:sp>
+        <p:nvSpPr>
+          <p:cNvPr id="20" name="Rectangle 19"/>
+          <p:cNvSpPr/>
+          <p:nvPr/>
+        </p:nvSpPr>
+        <p:spPr>
+          <a:xfrm>
+            <a:off x="658368" y="6291072"/>
+            <a:ext cx="10881360" cy="9144"/>
+          </a:xfrm>
+          <a:prstGeom prst="rect">
+            <a:avLst/>
+          </a:prstGeom>
+          <a:solidFill>
+            <a:srgbClr val="DDE7F0"/>
+          </a:solidFill>
+          <a:ln>
+            <a:solidFill>
+              <a:srgbClr val="DDE7F0"/>
+            </a:solidFill>
+          </a:ln>
+        </p:spPr>
+        <p:style>
+          <a:lnRef idx="1">
+            <a:schemeClr val="accent1"/>
+          </a:lnRef>
+          <a:fillRef idx="3">
+            <a:schemeClr val="accent1"/>
+          </a:fillRef>
+          <a:effectRef idx="2">
+            <a:schemeClr val="accent1"/>
+          </a:effectRef>
+          <a:fontRef idx="minor">
+            <a:schemeClr val="lt1"/>
+          </a:fontRef>
+        </p:style>
+        <p:txBody>
+          <a:bodyPr rtlCol="0" anchor="ctr"/>
+          <a:lstStyle/>
+          <a:p>
+            <a:pPr algn="ctr"/>
+          </a:p>
+        </p:txBody>
+      </p:sp>
+      <p:sp>
+        <p:nvSpPr>
+          <p:cNvPr id="21" name="TextBox 20"/>
           <p:cNvSpPr txBox="1"/>
           <p:nvPr/>
         </p:nvSpPr>
         <p:spPr>
           <a:xfrm>
-            <a:off x="4681727" y="4992624"/>
-            <a:ext cx="2743200" cy="256032"/>
+            <a:off x="658368" y="6428232"/>
+            <a:ext cx="2560320" cy="164592"/>
           </a:xfrm>
           <a:prstGeom prst="rect">
             <a:avLst/>
@@ -4004,27 +4260,27 @@
           <a:p>
             <a:pPr algn="l"/>
             <a:r>
-              <a:rPr sz="1700" b="1">
-                <a:solidFill>
-                  <a:srgbClr val="003E7E"/>
+              <a:rPr sz="900" b="0">
+                <a:solidFill>
+                  <a:srgbClr val="5C6874"/>
                 </a:solidFill>
                 <a:latin typeface="Arial"/>
               </a:rPr>
-              <a:t>Contactless</a:t>
-            </a:r>
-          </a:p>
-        </p:txBody>
-      </p:sp>
-      <p:sp>
-        <p:nvSpPr>
-          <p:cNvPr id="13" name="TextBox 12"/>
+              <a:t>ADIB Cards Portfolio</a:t>
+            </a:r>
+          </a:p>
+        </p:txBody>
+      </p:sp>
+      <p:sp>
+        <p:nvSpPr>
+          <p:cNvPr id="22" name="TextBox 21"/>
           <p:cNvSpPr txBox="1"/>
           <p:nvPr/>
         </p:nvSpPr>
         <p:spPr>
           <a:xfrm>
-            <a:off x="4681727" y="5376672"/>
-            <a:ext cx="2560320" cy="274320"/>
+            <a:off x="10927080" y="6428232"/>
+            <a:ext cx="594360" cy="164592"/>
           </a:xfrm>
           <a:prstGeom prst="rect">
             <a:avLst/>
@@ -4037,85 +4293,15 @@
           </a:bodyPr>
           <a:lstStyle/>
           <a:p>
-            <a:pPr algn="l"/>
-            <a:r>
-              <a:rPr sz="1200" b="0">
+            <a:pPr algn="r"/>
+            <a:r>
+              <a:rPr sz="900" b="0">
                 <a:solidFill>
                   <a:srgbClr val="5C6874"/>
                 </a:solidFill>
                 <a:latin typeface="Arial"/>
               </a:rPr>
-              <a:t>Quick everyday payments</a:t>
-            </a:r>
-          </a:p>
-        </p:txBody>
-      </p:sp>
-      <p:sp>
-        <p:nvSpPr>
-          <p:cNvPr id="14" name="TextBox 13"/>
-          <p:cNvSpPr txBox="1"/>
-          <p:nvPr/>
-        </p:nvSpPr>
-        <p:spPr>
-          <a:xfrm>
-            <a:off x="8467344" y="4992624"/>
-            <a:ext cx="2743200" cy="256032"/>
-          </a:xfrm>
-          <a:prstGeom prst="rect">
-            <a:avLst/>
-          </a:prstGeom>
-          <a:noFill/>
-        </p:spPr>
-        <p:txBody>
-          <a:bodyPr wrap="none" lIns="0" rIns="0" tIns="0" bIns="0">
-            <a:spAutoFit/>
-          </a:bodyPr>
-          <a:lstStyle/>
-          <a:p>
-            <a:pPr algn="l"/>
-            <a:r>
-              <a:rPr sz="1700" b="1">
-                <a:solidFill>
-                  <a:srgbClr val="003E7E"/>
-                </a:solidFill>
-                <a:latin typeface="Arial"/>
-              </a:rPr>
-              <a:t>Mastercard</a:t>
-            </a:r>
-          </a:p>
-        </p:txBody>
-      </p:sp>
-      <p:sp>
-        <p:nvSpPr>
-          <p:cNvPr id="15" name="TextBox 14"/>
-          <p:cNvSpPr txBox="1"/>
-          <p:nvPr/>
-        </p:nvSpPr>
-        <p:spPr>
-          <a:xfrm>
-            <a:off x="8467344" y="5376672"/>
-            <a:ext cx="2560320" cy="274320"/>
-          </a:xfrm>
-          <a:prstGeom prst="rect">
-            <a:avLst/>
-          </a:prstGeom>
-          <a:noFill/>
-        </p:spPr>
-        <p:txBody>
-          <a:bodyPr wrap="none" lIns="0" rIns="0" tIns="0" bIns="0">
-            <a:spAutoFit/>
-          </a:bodyPr>
-          <a:lstStyle/>
-          <a:p>
-            <a:pPr algn="l"/>
-            <a:r>
-              <a:rPr sz="1200" b="0">
-                <a:solidFill>
-                  <a:srgbClr val="5C6874"/>
-                </a:solidFill>
-                <a:latin typeface="Arial"/>
-              </a:rPr>
-              <a:t>Wide local and international acceptance</a:t>
+              <a:t>02</a:t>
             </a:r>
           </a:p>
         </p:txBody>
@@ -4134,7 +4320,7 @@
     <p:bg>
       <p:bgPr>
         <a:solidFill>
-          <a:srgbClr val="F6F9FC"/>
+          <a:srgbClr val="FFFFFF"/>
         </a:solidFill>
         <a:effectLst/>
       </p:bgPr>
@@ -4146,16 +4332,40 @@
         <p:nvPr/>
       </p:nvGrpSpPr>
       <p:grpSpPr/>
-      <p:sp>
-        <p:nvSpPr>
-          <p:cNvPr id="2" name="TextBox 1"/>
+      <p:pic>
+        <p:nvPicPr>
+          <p:cNvPr id="2" name="Picture 1" descr="adib_logo_transparent.png"/>
+          <p:cNvPicPr>
+            <a:picLocks noChangeAspect="1"/>
+          </p:cNvPicPr>
+          <p:nvPr/>
+        </p:nvPicPr>
+        <p:blipFill>
+          <a:blip r:embed="rId2"/>
+          <a:stretch>
+            <a:fillRect/>
+          </a:stretch>
+        </p:blipFill>
+        <p:spPr>
+          <a:xfrm>
+            <a:off x="658368" y="320040"/>
+            <a:ext cx="384048" cy="384048"/>
+          </a:xfrm>
+          <a:prstGeom prst="rect">
+            <a:avLst/>
+          </a:prstGeom>
+        </p:spPr>
+      </p:pic>
+      <p:sp>
+        <p:nvSpPr>
+          <p:cNvPr id="3" name="TextBox 2"/>
           <p:cNvSpPr txBox="1"/>
           <p:nvPr/>
         </p:nvSpPr>
         <p:spPr>
           <a:xfrm>
-            <a:off x="658368" y="384048"/>
-            <a:ext cx="8503920" cy="411480"/>
+            <a:off x="1115568" y="374904"/>
+            <a:ext cx="1097280" cy="256032"/>
           </a:xfrm>
           <a:prstGeom prst="rect">
             <a:avLst/>
@@ -4170,6 +4380,41 @@
           <a:p>
             <a:pPr algn="l"/>
             <a:r>
+              <a:rPr sz="1600" b="1">
+                <a:solidFill>
+                  <a:srgbClr val="003E7E"/>
+                </a:solidFill>
+                <a:latin typeface="Arial"/>
+              </a:rPr>
+              <a:t>ADIB</a:t>
+            </a:r>
+          </a:p>
+        </p:txBody>
+      </p:sp>
+      <p:sp>
+        <p:nvSpPr>
+          <p:cNvPr id="4" name="TextBox 3"/>
+          <p:cNvSpPr txBox="1"/>
+          <p:nvPr/>
+        </p:nvSpPr>
+        <p:spPr>
+          <a:xfrm>
+            <a:off x="658368" y="841248"/>
+            <a:ext cx="8503920" cy="411480"/>
+          </a:xfrm>
+          <a:prstGeom prst="rect">
+            <a:avLst/>
+          </a:prstGeom>
+          <a:noFill/>
+        </p:spPr>
+        <p:txBody>
+          <a:bodyPr wrap="none" lIns="0" rIns="0" tIns="0" bIns="0">
+            <a:spAutoFit/>
+          </a:bodyPr>
+          <a:lstStyle/>
+          <a:p>
+            <a:pPr algn="l"/>
+            <a:r>
               <a:rPr sz="2500" b="1">
                 <a:solidFill>
                   <a:srgbClr val="003E7E"/>
@@ -4183,13 +4428,13 @@
       </p:sp>
       <p:sp>
         <p:nvSpPr>
-          <p:cNvPr id="3" name="Rounded Rectangle 2"/>
+          <p:cNvPr id="5" name="Rounded Rectangle 4"/>
           <p:cNvSpPr/>
           <p:nvPr/>
         </p:nvSpPr>
         <p:spPr>
           <a:xfrm>
-            <a:off x="10012680" y="384048"/>
+            <a:off x="10012680" y="502920"/>
             <a:ext cx="1554480" cy="329184"/>
           </a:xfrm>
           <a:prstGeom prst="roundRect">
@@ -4228,13 +4473,13 @@
       </p:sp>
       <p:sp>
         <p:nvSpPr>
-          <p:cNvPr id="4" name="TextBox 3"/>
+          <p:cNvPr id="6" name="TextBox 5"/>
           <p:cNvSpPr txBox="1"/>
           <p:nvPr/>
         </p:nvSpPr>
         <p:spPr>
           <a:xfrm>
-            <a:off x="10158984" y="438912"/>
+            <a:off x="10158984" y="557784"/>
             <a:ext cx="1261872" cy="201168"/>
           </a:xfrm>
           <a:prstGeom prst="rect">
@@ -4263,24 +4508,24 @@
       </p:sp>
       <p:sp>
         <p:nvSpPr>
-          <p:cNvPr id="5" name="Rectangle 4"/>
+          <p:cNvPr id="7" name="Rectangle 6"/>
           <p:cNvSpPr/>
           <p:nvPr/>
         </p:nvSpPr>
         <p:spPr>
           <a:xfrm>
-            <a:off x="658368" y="932688"/>
+            <a:off x="658368" y="1344168"/>
             <a:ext cx="10881360" cy="18288"/>
           </a:xfrm>
           <a:prstGeom prst="rect">
             <a:avLst/>
           </a:prstGeom>
           <a:solidFill>
-            <a:srgbClr val="DBE5EF"/>
+            <a:srgbClr val="DDE7F0"/>
           </a:solidFill>
           <a:ln>
             <a:solidFill>
-              <a:srgbClr val="DBE5EF"/>
+              <a:srgbClr val="DDE7F0"/>
             </a:solidFill>
           </a:ln>
         </p:spPr>
@@ -4308,24 +4553,24 @@
       </p:sp>
       <p:sp>
         <p:nvSpPr>
-          <p:cNvPr id="6" name="Rounded Rectangle 5"/>
+          <p:cNvPr id="8" name="Rounded Rectangle 7"/>
           <p:cNvSpPr/>
           <p:nvPr/>
         </p:nvSpPr>
         <p:spPr>
           <a:xfrm>
-            <a:off x="658368" y="1298448"/>
-            <a:ext cx="5532120" cy="4370832"/>
+            <a:off x="713232" y="1874519"/>
+            <a:ext cx="3886200" cy="3401568"/>
           </a:xfrm>
           <a:prstGeom prst="roundRect">
             <a:avLst/>
           </a:prstGeom>
           <a:solidFill>
-            <a:srgbClr val="FFFFFF"/>
+            <a:srgbClr val="F6F9FC"/>
           </a:solidFill>
           <a:ln>
             <a:solidFill>
-              <a:srgbClr val="FFFFFF"/>
+              <a:srgbClr val="DDE7F0"/>
             </a:solidFill>
           </a:ln>
         </p:spPr>
@@ -4351,75 +4596,6 @@
           </a:p>
         </p:txBody>
       </p:sp>
-      <p:pic>
-        <p:nvPicPr>
-          <p:cNvPr id="7" name="Picture 6" descr="platinum_card.png"/>
-          <p:cNvPicPr>
-            <a:picLocks noChangeAspect="1"/>
-          </p:cNvPicPr>
-          <p:nvPr/>
-        </p:nvPicPr>
-        <p:blipFill>
-          <a:blip r:embed="rId2"/>
-          <a:stretch>
-            <a:fillRect/>
-          </a:stretch>
-        </p:blipFill>
-        <p:spPr>
-          <a:xfrm>
-            <a:off x="914400" y="1815787"/>
-            <a:ext cx="5029200" cy="3327009"/>
-          </a:xfrm>
-          <a:prstGeom prst="rect">
-            <a:avLst/>
-          </a:prstGeom>
-        </p:spPr>
-      </p:pic>
-      <p:sp>
-        <p:nvSpPr>
-          <p:cNvPr id="8" name="Rounded Rectangle 7"/>
-          <p:cNvSpPr/>
-          <p:nvPr/>
-        </p:nvSpPr>
-        <p:spPr>
-          <a:xfrm>
-            <a:off x="6720840" y="1417320"/>
-            <a:ext cx="4553712" cy="4133087"/>
-          </a:xfrm>
-          <a:prstGeom prst="roundRect">
-            <a:avLst/>
-          </a:prstGeom>
-          <a:solidFill>
-            <a:srgbClr val="FFFFFF"/>
-          </a:solidFill>
-          <a:ln>
-            <a:solidFill>
-              <a:srgbClr val="FFFFFF"/>
-            </a:solidFill>
-          </a:ln>
-        </p:spPr>
-        <p:style>
-          <a:lnRef idx="1">
-            <a:schemeClr val="accent1"/>
-          </a:lnRef>
-          <a:fillRef idx="3">
-            <a:schemeClr val="accent1"/>
-          </a:fillRef>
-          <a:effectRef idx="2">
-            <a:schemeClr val="accent1"/>
-          </a:effectRef>
-          <a:fontRef idx="minor">
-            <a:schemeClr val="lt1"/>
-          </a:fontRef>
-        </p:style>
-        <p:txBody>
-          <a:bodyPr rtlCol="0" anchor="ctr"/>
-          <a:lstStyle/>
-          <a:p>
-            <a:pPr algn="ctr"/>
-          </a:p>
-        </p:txBody>
-      </p:sp>
       <p:sp>
         <p:nvSpPr>
           <p:cNvPr id="9" name="Rectangle 8"/>
@@ -4428,8 +4604,8 @@
         </p:nvSpPr>
         <p:spPr>
           <a:xfrm>
-            <a:off x="6720840" y="1417320"/>
-            <a:ext cx="109728" cy="4133087"/>
+            <a:off x="713232" y="1874519"/>
+            <a:ext cx="100584" cy="3401568"/>
           </a:xfrm>
           <a:prstGeom prst="rect">
             <a:avLst/>
@@ -4473,8 +4649,8 @@
         </p:nvSpPr>
         <p:spPr>
           <a:xfrm>
-            <a:off x="7077456" y="1764792"/>
-            <a:ext cx="3474720" cy="384048"/>
+            <a:off x="1051560" y="2249424"/>
+            <a:ext cx="2926080" cy="320040"/>
           </a:xfrm>
           <a:prstGeom prst="rect">
             <a:avLst/>
@@ -4489,7 +4665,7 @@
           <a:p>
             <a:pPr algn="l"/>
             <a:r>
-              <a:rPr sz="2300" b="1">
+              <a:rPr sz="2200" b="1">
                 <a:solidFill>
                   <a:srgbClr val="003E7E"/>
                 </a:solidFill>
@@ -4508,8 +4684,8 @@
         </p:nvSpPr>
         <p:spPr>
           <a:xfrm>
-            <a:off x="7104888" y="2487168"/>
-            <a:ext cx="3584448" cy="2286000"/>
+            <a:off x="1078992" y="2907792"/>
+            <a:ext cx="3063240" cy="1691640"/>
           </a:xfrm>
           <a:prstGeom prst="rect">
             <a:avLst/>
@@ -4573,14 +4749,128 @@
       </p:sp>
       <p:sp>
         <p:nvSpPr>
-          <p:cNvPr id="12" name="TextBox 11"/>
+          <p:cNvPr id="12" name="Rounded Rectangle 11"/>
+          <p:cNvSpPr/>
+          <p:nvPr/>
+        </p:nvSpPr>
+        <p:spPr>
+          <a:xfrm>
+            <a:off x="5102352" y="1755648"/>
+            <a:ext cx="6236208" cy="3703320"/>
+          </a:xfrm>
+          <a:prstGeom prst="roundRect">
+            <a:avLst/>
+          </a:prstGeom>
+          <a:solidFill>
+            <a:srgbClr val="E8F4FB"/>
+          </a:solidFill>
+          <a:ln>
+            <a:solidFill>
+              <a:srgbClr val="E8F4FB"/>
+            </a:solidFill>
+          </a:ln>
+        </p:spPr>
+        <p:style>
+          <a:lnRef idx="1">
+            <a:schemeClr val="accent1"/>
+          </a:lnRef>
+          <a:fillRef idx="3">
+            <a:schemeClr val="accent1"/>
+          </a:fillRef>
+          <a:effectRef idx="2">
+            <a:schemeClr val="accent1"/>
+          </a:effectRef>
+          <a:fontRef idx="minor">
+            <a:schemeClr val="lt1"/>
+          </a:fontRef>
+        </p:style>
+        <p:txBody>
+          <a:bodyPr rtlCol="0" anchor="ctr"/>
+          <a:lstStyle/>
+          <a:p>
+            <a:pPr algn="ctr"/>
+          </a:p>
+        </p:txBody>
+      </p:sp>
+      <p:pic>
+        <p:nvPicPr>
+          <p:cNvPr id="13" name="Picture 12" descr="platinum_card.png"/>
+          <p:cNvPicPr>
+            <a:picLocks noChangeAspect="1"/>
+          </p:cNvPicPr>
+          <p:nvPr/>
+        </p:nvPicPr>
+        <p:blipFill>
+          <a:blip r:embed="rId3"/>
+          <a:stretch>
+            <a:fillRect/>
+          </a:stretch>
+        </p:blipFill>
+        <p:spPr>
+          <a:xfrm>
+            <a:off x="5822389" y="2029968"/>
+            <a:ext cx="4768702" cy="3154680"/>
+          </a:xfrm>
+          <a:prstGeom prst="rect">
+            <a:avLst/>
+          </a:prstGeom>
+        </p:spPr>
+      </p:pic>
+      <p:sp>
+        <p:nvSpPr>
+          <p:cNvPr id="14" name="Rectangle 13"/>
+          <p:cNvSpPr/>
+          <p:nvPr/>
+        </p:nvSpPr>
+        <p:spPr>
+          <a:xfrm>
+            <a:off x="658368" y="6291072"/>
+            <a:ext cx="10881360" cy="9144"/>
+          </a:xfrm>
+          <a:prstGeom prst="rect">
+            <a:avLst/>
+          </a:prstGeom>
+          <a:solidFill>
+            <a:srgbClr val="DDE7F0"/>
+          </a:solidFill>
+          <a:ln>
+            <a:solidFill>
+              <a:srgbClr val="DDE7F0"/>
+            </a:solidFill>
+          </a:ln>
+        </p:spPr>
+        <p:style>
+          <a:lnRef idx="1">
+            <a:schemeClr val="accent1"/>
+          </a:lnRef>
+          <a:fillRef idx="3">
+            <a:schemeClr val="accent1"/>
+          </a:fillRef>
+          <a:effectRef idx="2">
+            <a:schemeClr val="accent1"/>
+          </a:effectRef>
+          <a:fontRef idx="minor">
+            <a:schemeClr val="lt1"/>
+          </a:fontRef>
+        </p:style>
+        <p:txBody>
+          <a:bodyPr rtlCol="0" anchor="ctr"/>
+          <a:lstStyle/>
+          <a:p>
+            <a:pPr algn="ctr"/>
+          </a:p>
+        </p:txBody>
+      </p:sp>
+      <p:sp>
+        <p:nvSpPr>
+          <p:cNvPr id="15" name="TextBox 14"/>
           <p:cNvSpPr txBox="1"/>
           <p:nvPr/>
         </p:nvSpPr>
         <p:spPr>
           <a:xfrm>
-            <a:off x="7104888" y="5010912"/>
-            <a:ext cx="3520440" cy="228600"/>
+            <a:off x="658368" y="6428232"/>
+            <a:ext cx="2560320" cy="164592"/>
           </a:xfrm>
           <a:prstGeom prst="rect">
             <a:avLst/>
@@ -4595,13 +4885,48 @@
           <a:p>
             <a:pPr algn="l"/>
             <a:r>
-              <a:rPr sz="1100" b="0">
+              <a:rPr sz="900" b="0">
                 <a:solidFill>
                   <a:srgbClr val="5C6874"/>
                 </a:solidFill>
                 <a:latin typeface="Arial"/>
               </a:rPr>
-              <a:t>Visual focus: large card image + short text only.</a:t>
+              <a:t>ADIB Cards Portfolio</a:t>
+            </a:r>
+          </a:p>
+        </p:txBody>
+      </p:sp>
+      <p:sp>
+        <p:nvSpPr>
+          <p:cNvPr id="16" name="TextBox 15"/>
+          <p:cNvSpPr txBox="1"/>
+          <p:nvPr/>
+        </p:nvSpPr>
+        <p:spPr>
+          <a:xfrm>
+            <a:off x="10927080" y="6428232"/>
+            <a:ext cx="594360" cy="164592"/>
+          </a:xfrm>
+          <a:prstGeom prst="rect">
+            <a:avLst/>
+          </a:prstGeom>
+          <a:noFill/>
+        </p:spPr>
+        <p:txBody>
+          <a:bodyPr wrap="none" lIns="0" rIns="0" tIns="0" bIns="0">
+            <a:spAutoFit/>
+          </a:bodyPr>
+          <a:lstStyle/>
+          <a:p>
+            <a:pPr algn="r"/>
+            <a:r>
+              <a:rPr sz="900" b="0">
+                <a:solidFill>
+                  <a:srgbClr val="5C6874"/>
+                </a:solidFill>
+                <a:latin typeface="Arial"/>
+              </a:rPr>
+              <a:t>03</a:t>
             </a:r>
           </a:p>
         </p:txBody>
@@ -4620,7 +4945,7 @@
     <p:bg>
       <p:bgPr>
         <a:solidFill>
-          <a:srgbClr val="F6F9FC"/>
+          <a:srgbClr val="FFFFFF"/>
         </a:solidFill>
         <a:effectLst/>
       </p:bgPr>
@@ -4632,16 +4957,40 @@
         <p:nvPr/>
       </p:nvGrpSpPr>
       <p:grpSpPr/>
-      <p:sp>
-        <p:nvSpPr>
-          <p:cNvPr id="2" name="TextBox 1"/>
+      <p:pic>
+        <p:nvPicPr>
+          <p:cNvPr id="2" name="Picture 1" descr="adib_logo_transparent.png"/>
+          <p:cNvPicPr>
+            <a:picLocks noChangeAspect="1"/>
+          </p:cNvPicPr>
+          <p:nvPr/>
+        </p:nvPicPr>
+        <p:blipFill>
+          <a:blip r:embed="rId2"/>
+          <a:stretch>
+            <a:fillRect/>
+          </a:stretch>
+        </p:blipFill>
+        <p:spPr>
+          <a:xfrm>
+            <a:off x="658368" y="320040"/>
+            <a:ext cx="384048" cy="384048"/>
+          </a:xfrm>
+          <a:prstGeom prst="rect">
+            <a:avLst/>
+          </a:prstGeom>
+        </p:spPr>
+      </p:pic>
+      <p:sp>
+        <p:nvSpPr>
+          <p:cNvPr id="3" name="TextBox 2"/>
           <p:cNvSpPr txBox="1"/>
           <p:nvPr/>
         </p:nvSpPr>
         <p:spPr>
           <a:xfrm>
-            <a:off x="658368" y="384048"/>
-            <a:ext cx="8503920" cy="411480"/>
+            <a:off x="1115568" y="374904"/>
+            <a:ext cx="1097280" cy="256032"/>
           </a:xfrm>
           <a:prstGeom prst="rect">
             <a:avLst/>
@@ -4656,6 +5005,41 @@
           <a:p>
             <a:pPr algn="l"/>
             <a:r>
+              <a:rPr sz="1600" b="1">
+                <a:solidFill>
+                  <a:srgbClr val="003E7E"/>
+                </a:solidFill>
+                <a:latin typeface="Arial"/>
+              </a:rPr>
+              <a:t>ADIB</a:t>
+            </a:r>
+          </a:p>
+        </p:txBody>
+      </p:sp>
+      <p:sp>
+        <p:nvSpPr>
+          <p:cNvPr id="4" name="TextBox 3"/>
+          <p:cNvSpPr txBox="1"/>
+          <p:nvPr/>
+        </p:nvSpPr>
+        <p:spPr>
+          <a:xfrm>
+            <a:off x="658368" y="841248"/>
+            <a:ext cx="8503920" cy="411480"/>
+          </a:xfrm>
+          <a:prstGeom prst="rect">
+            <a:avLst/>
+          </a:prstGeom>
+          <a:noFill/>
+        </p:spPr>
+        <p:txBody>
+          <a:bodyPr wrap="none" lIns="0" rIns="0" tIns="0" bIns="0">
+            <a:spAutoFit/>
+          </a:bodyPr>
+          <a:lstStyle/>
+          <a:p>
+            <a:pPr algn="l"/>
+            <a:r>
               <a:rPr sz="2500" b="1">
                 <a:solidFill>
                   <a:srgbClr val="003E7E"/>
@@ -4669,13 +5053,13 @@
       </p:sp>
       <p:sp>
         <p:nvSpPr>
-          <p:cNvPr id="3" name="Rounded Rectangle 2"/>
+          <p:cNvPr id="5" name="Rounded Rectangle 4"/>
           <p:cNvSpPr/>
           <p:nvPr/>
         </p:nvSpPr>
         <p:spPr>
           <a:xfrm>
-            <a:off x="10012680" y="384048"/>
+            <a:off x="10012680" y="502920"/>
             <a:ext cx="1554480" cy="329184"/>
           </a:xfrm>
           <a:prstGeom prst="roundRect">
@@ -4714,13 +5098,13 @@
       </p:sp>
       <p:sp>
         <p:nvSpPr>
-          <p:cNvPr id="4" name="TextBox 3"/>
+          <p:cNvPr id="6" name="TextBox 5"/>
           <p:cNvSpPr txBox="1"/>
           <p:nvPr/>
         </p:nvSpPr>
         <p:spPr>
           <a:xfrm>
-            <a:off x="10158984" y="438912"/>
+            <a:off x="10158984" y="557784"/>
             <a:ext cx="1261872" cy="201168"/>
           </a:xfrm>
           <a:prstGeom prst="rect">
@@ -4749,24 +5133,24 @@
       </p:sp>
       <p:sp>
         <p:nvSpPr>
-          <p:cNvPr id="5" name="Rectangle 4"/>
+          <p:cNvPr id="7" name="Rectangle 6"/>
           <p:cNvSpPr/>
           <p:nvPr/>
         </p:nvSpPr>
         <p:spPr>
           <a:xfrm>
-            <a:off x="658368" y="932688"/>
+            <a:off x="658368" y="1344168"/>
             <a:ext cx="10881360" cy="18288"/>
           </a:xfrm>
           <a:prstGeom prst="rect">
             <a:avLst/>
           </a:prstGeom>
           <a:solidFill>
-            <a:srgbClr val="DBE5EF"/>
+            <a:srgbClr val="DDE7F0"/>
           </a:solidFill>
           <a:ln>
             <a:solidFill>
-              <a:srgbClr val="DBE5EF"/>
+              <a:srgbClr val="DDE7F0"/>
             </a:solidFill>
           </a:ln>
         </p:spPr>
@@ -4794,24 +5178,24 @@
       </p:sp>
       <p:sp>
         <p:nvSpPr>
-          <p:cNvPr id="6" name="Rounded Rectangle 5"/>
+          <p:cNvPr id="8" name="Rounded Rectangle 7"/>
           <p:cNvSpPr/>
           <p:nvPr/>
         </p:nvSpPr>
         <p:spPr>
           <a:xfrm>
-            <a:off x="658368" y="1298448"/>
-            <a:ext cx="5532120" cy="4370832"/>
+            <a:off x="713232" y="1874519"/>
+            <a:ext cx="3886200" cy="3401568"/>
           </a:xfrm>
           <a:prstGeom prst="roundRect">
             <a:avLst/>
           </a:prstGeom>
           <a:solidFill>
-            <a:srgbClr val="FFFFFF"/>
+            <a:srgbClr val="F6F9FC"/>
           </a:solidFill>
           <a:ln>
             <a:solidFill>
-              <a:srgbClr val="FFFFFF"/>
+              <a:srgbClr val="DDE7F0"/>
             </a:solidFill>
           </a:ln>
         </p:spPr>
@@ -4837,75 +5221,6 @@
           </a:p>
         </p:txBody>
       </p:sp>
-      <p:pic>
-        <p:nvPicPr>
-          <p:cNvPr id="7" name="Picture 6" descr="titanium_card.png"/>
-          <p:cNvPicPr>
-            <a:picLocks noChangeAspect="1"/>
-          </p:cNvPicPr>
-          <p:nvPr/>
-        </p:nvPicPr>
-        <p:blipFill>
-          <a:blip r:embed="rId2"/>
-          <a:stretch>
-            <a:fillRect/>
-          </a:stretch>
-        </p:blipFill>
-        <p:spPr>
-          <a:xfrm>
-            <a:off x="914400" y="1815787"/>
-            <a:ext cx="5029200" cy="3327009"/>
-          </a:xfrm>
-          <a:prstGeom prst="rect">
-            <a:avLst/>
-          </a:prstGeom>
-        </p:spPr>
-      </p:pic>
-      <p:sp>
-        <p:nvSpPr>
-          <p:cNvPr id="8" name="Rounded Rectangle 7"/>
-          <p:cNvSpPr/>
-          <p:nvPr/>
-        </p:nvSpPr>
-        <p:spPr>
-          <a:xfrm>
-            <a:off x="6720840" y="1417320"/>
-            <a:ext cx="4553712" cy="4133087"/>
-          </a:xfrm>
-          <a:prstGeom prst="roundRect">
-            <a:avLst/>
-          </a:prstGeom>
-          <a:solidFill>
-            <a:srgbClr val="FFFFFF"/>
-          </a:solidFill>
-          <a:ln>
-            <a:solidFill>
-              <a:srgbClr val="FFFFFF"/>
-            </a:solidFill>
-          </a:ln>
-        </p:spPr>
-        <p:style>
-          <a:lnRef idx="1">
-            <a:schemeClr val="accent1"/>
-          </a:lnRef>
-          <a:fillRef idx="3">
-            <a:schemeClr val="accent1"/>
-          </a:fillRef>
-          <a:effectRef idx="2">
-            <a:schemeClr val="accent1"/>
-          </a:effectRef>
-          <a:fontRef idx="minor">
-            <a:schemeClr val="lt1"/>
-          </a:fontRef>
-        </p:style>
-        <p:txBody>
-          <a:bodyPr rtlCol="0" anchor="ctr"/>
-          <a:lstStyle/>
-          <a:p>
-            <a:pPr algn="ctr"/>
-          </a:p>
-        </p:txBody>
-      </p:sp>
       <p:sp>
         <p:nvSpPr>
           <p:cNvPr id="9" name="Rectangle 8"/>
@@ -4914,8 +5229,8 @@
         </p:nvSpPr>
         <p:spPr>
           <a:xfrm>
-            <a:off x="6720840" y="1417320"/>
-            <a:ext cx="109728" cy="4133087"/>
+            <a:off x="713232" y="1874519"/>
+            <a:ext cx="100584" cy="3401568"/>
           </a:xfrm>
           <a:prstGeom prst="rect">
             <a:avLst/>
@@ -4959,8 +5274,8 @@
         </p:nvSpPr>
         <p:spPr>
           <a:xfrm>
-            <a:off x="7077456" y="1764792"/>
-            <a:ext cx="3474720" cy="384048"/>
+            <a:off x="1051560" y="2249424"/>
+            <a:ext cx="2926080" cy="320040"/>
           </a:xfrm>
           <a:prstGeom prst="rect">
             <a:avLst/>
@@ -4975,7 +5290,7 @@
           <a:p>
             <a:pPr algn="l"/>
             <a:r>
-              <a:rPr sz="2300" b="1">
+              <a:rPr sz="2200" b="1">
                 <a:solidFill>
                   <a:srgbClr val="003E7E"/>
                 </a:solidFill>
@@ -4994,8 +5309,8 @@
         </p:nvSpPr>
         <p:spPr>
           <a:xfrm>
-            <a:off x="7104888" y="2487168"/>
-            <a:ext cx="3584448" cy="2286000"/>
+            <a:off x="1078992" y="2907792"/>
+            <a:ext cx="3063240" cy="1691640"/>
           </a:xfrm>
           <a:prstGeom prst="rect">
             <a:avLst/>
@@ -5059,14 +5374,128 @@
       </p:sp>
       <p:sp>
         <p:nvSpPr>
-          <p:cNvPr id="12" name="TextBox 11"/>
+          <p:cNvPr id="12" name="Rounded Rectangle 11"/>
+          <p:cNvSpPr/>
+          <p:nvPr/>
+        </p:nvSpPr>
+        <p:spPr>
+          <a:xfrm>
+            <a:off x="5102352" y="1755648"/>
+            <a:ext cx="6236208" cy="3703320"/>
+          </a:xfrm>
+          <a:prstGeom prst="roundRect">
+            <a:avLst/>
+          </a:prstGeom>
+          <a:solidFill>
+            <a:srgbClr val="E8F4FB"/>
+          </a:solidFill>
+          <a:ln>
+            <a:solidFill>
+              <a:srgbClr val="E8F4FB"/>
+            </a:solidFill>
+          </a:ln>
+        </p:spPr>
+        <p:style>
+          <a:lnRef idx="1">
+            <a:schemeClr val="accent1"/>
+          </a:lnRef>
+          <a:fillRef idx="3">
+            <a:schemeClr val="accent1"/>
+          </a:fillRef>
+          <a:effectRef idx="2">
+            <a:schemeClr val="accent1"/>
+          </a:effectRef>
+          <a:fontRef idx="minor">
+            <a:schemeClr val="lt1"/>
+          </a:fontRef>
+        </p:style>
+        <p:txBody>
+          <a:bodyPr rtlCol="0" anchor="ctr"/>
+          <a:lstStyle/>
+          <a:p>
+            <a:pPr algn="ctr"/>
+          </a:p>
+        </p:txBody>
+      </p:sp>
+      <p:pic>
+        <p:nvPicPr>
+          <p:cNvPr id="13" name="Picture 12" descr="titanium_card.png"/>
+          <p:cNvPicPr>
+            <a:picLocks noChangeAspect="1"/>
+          </p:cNvPicPr>
+          <p:nvPr/>
+        </p:nvPicPr>
+        <p:blipFill>
+          <a:blip r:embed="rId3"/>
+          <a:stretch>
+            <a:fillRect/>
+          </a:stretch>
+        </p:blipFill>
+        <p:spPr>
+          <a:xfrm>
+            <a:off x="5822389" y="2029968"/>
+            <a:ext cx="4768702" cy="3154680"/>
+          </a:xfrm>
+          <a:prstGeom prst="rect">
+            <a:avLst/>
+          </a:prstGeom>
+        </p:spPr>
+      </p:pic>
+      <p:sp>
+        <p:nvSpPr>
+          <p:cNvPr id="14" name="Rectangle 13"/>
+          <p:cNvSpPr/>
+          <p:nvPr/>
+        </p:nvSpPr>
+        <p:spPr>
+          <a:xfrm>
+            <a:off x="658368" y="6291072"/>
+            <a:ext cx="10881360" cy="9144"/>
+          </a:xfrm>
+          <a:prstGeom prst="rect">
+            <a:avLst/>
+          </a:prstGeom>
+          <a:solidFill>
+            <a:srgbClr val="DDE7F0"/>
+          </a:solidFill>
+          <a:ln>
+            <a:solidFill>
+              <a:srgbClr val="DDE7F0"/>
+            </a:solidFill>
+          </a:ln>
+        </p:spPr>
+        <p:style>
+          <a:lnRef idx="1">
+            <a:schemeClr val="accent1"/>
+          </a:lnRef>
+          <a:fillRef idx="3">
+            <a:schemeClr val="accent1"/>
+          </a:fillRef>
+          <a:effectRef idx="2">
+            <a:schemeClr val="accent1"/>
+          </a:effectRef>
+          <a:fontRef idx="minor">
+            <a:schemeClr val="lt1"/>
+          </a:fontRef>
+        </p:style>
+        <p:txBody>
+          <a:bodyPr rtlCol="0" anchor="ctr"/>
+          <a:lstStyle/>
+          <a:p>
+            <a:pPr algn="ctr"/>
+          </a:p>
+        </p:txBody>
+      </p:sp>
+      <p:sp>
+        <p:nvSpPr>
+          <p:cNvPr id="15" name="TextBox 14"/>
           <p:cNvSpPr txBox="1"/>
           <p:nvPr/>
         </p:nvSpPr>
         <p:spPr>
           <a:xfrm>
-            <a:off x="7104888" y="5010912"/>
-            <a:ext cx="3520440" cy="228600"/>
+            <a:off x="658368" y="6428232"/>
+            <a:ext cx="2560320" cy="164592"/>
           </a:xfrm>
           <a:prstGeom prst="rect">
             <a:avLst/>
@@ -5081,13 +5510,48 @@
           <a:p>
             <a:pPr algn="l"/>
             <a:r>
-              <a:rPr sz="1100" b="0">
+              <a:rPr sz="900" b="0">
                 <a:solidFill>
                   <a:srgbClr val="5C6874"/>
                 </a:solidFill>
                 <a:latin typeface="Arial"/>
               </a:rPr>
-              <a:t>Visual focus: large card image + short text only.</a:t>
+              <a:t>ADIB Cards Portfolio</a:t>
+            </a:r>
+          </a:p>
+        </p:txBody>
+      </p:sp>
+      <p:sp>
+        <p:nvSpPr>
+          <p:cNvPr id="16" name="TextBox 15"/>
+          <p:cNvSpPr txBox="1"/>
+          <p:nvPr/>
+        </p:nvSpPr>
+        <p:spPr>
+          <a:xfrm>
+            <a:off x="10927080" y="6428232"/>
+            <a:ext cx="594360" cy="164592"/>
+          </a:xfrm>
+          <a:prstGeom prst="rect">
+            <a:avLst/>
+          </a:prstGeom>
+          <a:noFill/>
+        </p:spPr>
+        <p:txBody>
+          <a:bodyPr wrap="none" lIns="0" rIns="0" tIns="0" bIns="0">
+            <a:spAutoFit/>
+          </a:bodyPr>
+          <a:lstStyle/>
+          <a:p>
+            <a:pPr algn="r"/>
+            <a:r>
+              <a:rPr sz="900" b="0">
+                <a:solidFill>
+                  <a:srgbClr val="5C6874"/>
+                </a:solidFill>
+                <a:latin typeface="Arial"/>
+              </a:rPr>
+              <a:t>04</a:t>
             </a:r>
           </a:p>
         </p:txBody>
@@ -5118,16 +5582,40 @@
         <p:nvPr/>
       </p:nvGrpSpPr>
       <p:grpSpPr/>
-      <p:sp>
-        <p:nvSpPr>
-          <p:cNvPr id="2" name="TextBox 1"/>
+      <p:pic>
+        <p:nvPicPr>
+          <p:cNvPr id="2" name="Picture 1" descr="adib_logo_transparent.png"/>
+          <p:cNvPicPr>
+            <a:picLocks noChangeAspect="1"/>
+          </p:cNvPicPr>
+          <p:nvPr/>
+        </p:nvPicPr>
+        <p:blipFill>
+          <a:blip r:embed="rId2"/>
+          <a:stretch>
+            <a:fillRect/>
+          </a:stretch>
+        </p:blipFill>
+        <p:spPr>
+          <a:xfrm>
+            <a:off x="658368" y="320040"/>
+            <a:ext cx="384048" cy="384048"/>
+          </a:xfrm>
+          <a:prstGeom prst="rect">
+            <a:avLst/>
+          </a:prstGeom>
+        </p:spPr>
+      </p:pic>
+      <p:sp>
+        <p:nvSpPr>
+          <p:cNvPr id="3" name="TextBox 2"/>
           <p:cNvSpPr txBox="1"/>
           <p:nvPr/>
         </p:nvSpPr>
         <p:spPr>
           <a:xfrm>
-            <a:off x="658368" y="384048"/>
-            <a:ext cx="8503920" cy="411480"/>
+            <a:off x="1115568" y="374904"/>
+            <a:ext cx="1097280" cy="256032"/>
           </a:xfrm>
           <a:prstGeom prst="rect">
             <a:avLst/>
@@ -5142,6 +5630,41 @@
           <a:p>
             <a:pPr algn="l"/>
             <a:r>
+              <a:rPr sz="1600" b="1">
+                <a:solidFill>
+                  <a:srgbClr val="003E7E"/>
+                </a:solidFill>
+                <a:latin typeface="Arial"/>
+              </a:rPr>
+              <a:t>ADIB</a:t>
+            </a:r>
+          </a:p>
+        </p:txBody>
+      </p:sp>
+      <p:sp>
+        <p:nvSpPr>
+          <p:cNvPr id="4" name="TextBox 3"/>
+          <p:cNvSpPr txBox="1"/>
+          <p:nvPr/>
+        </p:nvSpPr>
+        <p:spPr>
+          <a:xfrm>
+            <a:off x="658368" y="841248"/>
+            <a:ext cx="8503920" cy="411480"/>
+          </a:xfrm>
+          <a:prstGeom prst="rect">
+            <a:avLst/>
+          </a:prstGeom>
+          <a:noFill/>
+        </p:spPr>
+        <p:txBody>
+          <a:bodyPr wrap="none" lIns="0" rIns="0" tIns="0" bIns="0">
+            <a:spAutoFit/>
+          </a:bodyPr>
+          <a:lstStyle/>
+          <a:p>
+            <a:pPr algn="l"/>
+            <a:r>
               <a:rPr sz="2500" b="1">
                 <a:solidFill>
                   <a:srgbClr val="003E7E"/>
@@ -5155,13 +5678,13 @@
       </p:sp>
       <p:sp>
         <p:nvSpPr>
-          <p:cNvPr id="3" name="Rounded Rectangle 2"/>
+          <p:cNvPr id="5" name="Rounded Rectangle 4"/>
           <p:cNvSpPr/>
           <p:nvPr/>
         </p:nvSpPr>
         <p:spPr>
           <a:xfrm>
-            <a:off x="10012680" y="384048"/>
+            <a:off x="10012680" y="502920"/>
             <a:ext cx="1554480" cy="329184"/>
           </a:xfrm>
           <a:prstGeom prst="roundRect">
@@ -5200,13 +5723,13 @@
       </p:sp>
       <p:sp>
         <p:nvSpPr>
-          <p:cNvPr id="4" name="TextBox 3"/>
+          <p:cNvPr id="6" name="TextBox 5"/>
           <p:cNvSpPr txBox="1"/>
           <p:nvPr/>
         </p:nvSpPr>
         <p:spPr>
           <a:xfrm>
-            <a:off x="10158984" y="438912"/>
+            <a:off x="10158984" y="557784"/>
             <a:ext cx="1261872" cy="201168"/>
           </a:xfrm>
           <a:prstGeom prst="rect">
@@ -5235,24 +5758,24 @@
       </p:sp>
       <p:sp>
         <p:nvSpPr>
-          <p:cNvPr id="5" name="Rectangle 4"/>
+          <p:cNvPr id="7" name="Rectangle 6"/>
           <p:cNvSpPr/>
           <p:nvPr/>
         </p:nvSpPr>
         <p:spPr>
           <a:xfrm>
-            <a:off x="658368" y="932688"/>
+            <a:off x="658368" y="1344168"/>
             <a:ext cx="10881360" cy="18288"/>
           </a:xfrm>
           <a:prstGeom prst="rect">
             <a:avLst/>
           </a:prstGeom>
           <a:solidFill>
-            <a:srgbClr val="DBE5EF"/>
+            <a:srgbClr val="DDE7F0"/>
           </a:solidFill>
           <a:ln>
             <a:solidFill>
-              <a:srgbClr val="DBE5EF"/>
+              <a:srgbClr val="DDE7F0"/>
             </a:solidFill>
           </a:ln>
         </p:spPr>
@@ -5280,16 +5803,336 @@
       </p:sp>
       <p:sp>
         <p:nvSpPr>
-          <p:cNvPr id="6" name="Rounded Rectangle 5"/>
+          <p:cNvPr id="8" name="Rectangle 7"/>
           <p:cNvSpPr/>
           <p:nvPr/>
         </p:nvSpPr>
         <p:spPr>
           <a:xfrm>
-            <a:off x="713232" y="1325880"/>
-            <a:ext cx="3310128" cy="4526280"/>
-          </a:xfrm>
-          <a:prstGeom prst="roundRect">
+            <a:off x="777240" y="1874519"/>
+            <a:ext cx="2286000" cy="594360"/>
+          </a:xfrm>
+          <a:prstGeom prst="rect">
+            <a:avLst/>
+          </a:prstGeom>
+          <a:solidFill>
+            <a:srgbClr val="003E7E"/>
+          </a:solidFill>
+          <a:ln>
+            <a:solidFill>
+              <a:srgbClr val="003E7E"/>
+            </a:solidFill>
+          </a:ln>
+        </p:spPr>
+        <p:style>
+          <a:lnRef idx="1">
+            <a:schemeClr val="accent1"/>
+          </a:lnRef>
+          <a:fillRef idx="3">
+            <a:schemeClr val="accent1"/>
+          </a:fillRef>
+          <a:effectRef idx="2">
+            <a:schemeClr val="accent1"/>
+          </a:effectRef>
+          <a:fontRef idx="minor">
+            <a:schemeClr val="lt1"/>
+          </a:fontRef>
+        </p:style>
+        <p:txBody>
+          <a:bodyPr rtlCol="0" anchor="ctr"/>
+          <a:lstStyle/>
+          <a:p>
+            <a:pPr algn="ctr"/>
+          </a:p>
+        </p:txBody>
+      </p:sp>
+      <p:sp>
+        <p:nvSpPr>
+          <p:cNvPr id="9" name="TextBox 8"/>
+          <p:cNvSpPr txBox="1"/>
+          <p:nvPr/>
+        </p:nvSpPr>
+        <p:spPr>
+          <a:xfrm>
+            <a:off x="923544" y="2057399"/>
+            <a:ext cx="1993392" cy="164592"/>
+          </a:xfrm>
+          <a:prstGeom prst="rect">
+            <a:avLst/>
+          </a:prstGeom>
+          <a:noFill/>
+        </p:spPr>
+        <p:txBody>
+          <a:bodyPr wrap="none" lIns="0" rIns="0" tIns="0" bIns="0">
+            <a:spAutoFit/>
+          </a:bodyPr>
+          <a:lstStyle/>
+          <a:p>
+            <a:pPr algn="l"/>
+            <a:r>
+              <a:rPr sz="1000" b="1">
+                <a:solidFill>
+                  <a:srgbClr val="FFFFFF"/>
+                </a:solidFill>
+                <a:latin typeface="Arial"/>
+              </a:rPr>
+              <a:t>Product</a:t>
+            </a:r>
+          </a:p>
+        </p:txBody>
+      </p:sp>
+      <p:sp>
+        <p:nvSpPr>
+          <p:cNvPr id="10" name="Rectangle 9"/>
+          <p:cNvSpPr/>
+          <p:nvPr/>
+        </p:nvSpPr>
+        <p:spPr>
+          <a:xfrm>
+            <a:off x="3063240" y="1874519"/>
+            <a:ext cx="2743200" cy="594360"/>
+          </a:xfrm>
+          <a:prstGeom prst="rect">
+            <a:avLst/>
+          </a:prstGeom>
+          <a:solidFill>
+            <a:srgbClr val="003E7E"/>
+          </a:solidFill>
+          <a:ln>
+            <a:solidFill>
+              <a:srgbClr val="003E7E"/>
+            </a:solidFill>
+          </a:ln>
+        </p:spPr>
+        <p:style>
+          <a:lnRef idx="1">
+            <a:schemeClr val="accent1"/>
+          </a:lnRef>
+          <a:fillRef idx="3">
+            <a:schemeClr val="accent1"/>
+          </a:fillRef>
+          <a:effectRef idx="2">
+            <a:schemeClr val="accent1"/>
+          </a:effectRef>
+          <a:fontRef idx="minor">
+            <a:schemeClr val="lt1"/>
+          </a:fontRef>
+        </p:style>
+        <p:txBody>
+          <a:bodyPr rtlCol="0" anchor="ctr"/>
+          <a:lstStyle/>
+          <a:p>
+            <a:pPr algn="ctr"/>
+          </a:p>
+        </p:txBody>
+      </p:sp>
+      <p:sp>
+        <p:nvSpPr>
+          <p:cNvPr id="11" name="TextBox 10"/>
+          <p:cNvSpPr txBox="1"/>
+          <p:nvPr/>
+        </p:nvSpPr>
+        <p:spPr>
+          <a:xfrm>
+            <a:off x="3209544" y="2057399"/>
+            <a:ext cx="2450592" cy="164592"/>
+          </a:xfrm>
+          <a:prstGeom prst="rect">
+            <a:avLst/>
+          </a:prstGeom>
+          <a:noFill/>
+        </p:spPr>
+        <p:txBody>
+          <a:bodyPr wrap="none" lIns="0" rIns="0" tIns="0" bIns="0">
+            <a:spAutoFit/>
+          </a:bodyPr>
+          <a:lstStyle/>
+          <a:p>
+            <a:pPr algn="l"/>
+            <a:r>
+              <a:rPr sz="1000" b="1">
+                <a:solidFill>
+                  <a:srgbClr val="FFFFFF"/>
+                </a:solidFill>
+                <a:latin typeface="Arial"/>
+              </a:rPr>
+              <a:t>Visual tone</a:t>
+            </a:r>
+          </a:p>
+        </p:txBody>
+      </p:sp>
+      <p:sp>
+        <p:nvSpPr>
+          <p:cNvPr id="12" name="Rectangle 11"/>
+          <p:cNvSpPr/>
+          <p:nvPr/>
+        </p:nvSpPr>
+        <p:spPr>
+          <a:xfrm>
+            <a:off x="5806440" y="1874519"/>
+            <a:ext cx="2880360" cy="594360"/>
+          </a:xfrm>
+          <a:prstGeom prst="rect">
+            <a:avLst/>
+          </a:prstGeom>
+          <a:solidFill>
+            <a:srgbClr val="003E7E"/>
+          </a:solidFill>
+          <a:ln>
+            <a:solidFill>
+              <a:srgbClr val="003E7E"/>
+            </a:solidFill>
+          </a:ln>
+        </p:spPr>
+        <p:style>
+          <a:lnRef idx="1">
+            <a:schemeClr val="accent1"/>
+          </a:lnRef>
+          <a:fillRef idx="3">
+            <a:schemeClr val="accent1"/>
+          </a:fillRef>
+          <a:effectRef idx="2">
+            <a:schemeClr val="accent1"/>
+          </a:effectRef>
+          <a:fontRef idx="minor">
+            <a:schemeClr val="lt1"/>
+          </a:fontRef>
+        </p:style>
+        <p:txBody>
+          <a:bodyPr rtlCol="0" anchor="ctr"/>
+          <a:lstStyle/>
+          <a:p>
+            <a:pPr algn="ctr"/>
+          </a:p>
+        </p:txBody>
+      </p:sp>
+      <p:sp>
+        <p:nvSpPr>
+          <p:cNvPr id="13" name="TextBox 12"/>
+          <p:cNvSpPr txBox="1"/>
+          <p:nvPr/>
+        </p:nvSpPr>
+        <p:spPr>
+          <a:xfrm>
+            <a:off x="5952744" y="2057399"/>
+            <a:ext cx="2587752" cy="164592"/>
+          </a:xfrm>
+          <a:prstGeom prst="rect">
+            <a:avLst/>
+          </a:prstGeom>
+          <a:noFill/>
+        </p:spPr>
+        <p:txBody>
+          <a:bodyPr wrap="none" lIns="0" rIns="0" tIns="0" bIns="0">
+            <a:spAutoFit/>
+          </a:bodyPr>
+          <a:lstStyle/>
+          <a:p>
+            <a:pPr algn="l"/>
+            <a:r>
+              <a:rPr sz="1000" b="1">
+                <a:solidFill>
+                  <a:srgbClr val="FFFFFF"/>
+                </a:solidFill>
+                <a:latin typeface="Arial"/>
+              </a:rPr>
+              <a:t>Positioning</a:t>
+            </a:r>
+          </a:p>
+        </p:txBody>
+      </p:sp>
+      <p:sp>
+        <p:nvSpPr>
+          <p:cNvPr id="14" name="Rectangle 13"/>
+          <p:cNvSpPr/>
+          <p:nvPr/>
+        </p:nvSpPr>
+        <p:spPr>
+          <a:xfrm>
+            <a:off x="8686800" y="1874519"/>
+            <a:ext cx="2468880" cy="594360"/>
+          </a:xfrm>
+          <a:prstGeom prst="rect">
+            <a:avLst/>
+          </a:prstGeom>
+          <a:solidFill>
+            <a:srgbClr val="003E7E"/>
+          </a:solidFill>
+          <a:ln>
+            <a:solidFill>
+              <a:srgbClr val="003E7E"/>
+            </a:solidFill>
+          </a:ln>
+        </p:spPr>
+        <p:style>
+          <a:lnRef idx="1">
+            <a:schemeClr val="accent1"/>
+          </a:lnRef>
+          <a:fillRef idx="3">
+            <a:schemeClr val="accent1"/>
+          </a:fillRef>
+          <a:effectRef idx="2">
+            <a:schemeClr val="accent1"/>
+          </a:effectRef>
+          <a:fontRef idx="minor">
+            <a:schemeClr val="lt1"/>
+          </a:fontRef>
+        </p:style>
+        <p:txBody>
+          <a:bodyPr rtlCol="0" anchor="ctr"/>
+          <a:lstStyle/>
+          <a:p>
+            <a:pPr algn="ctr"/>
+          </a:p>
+        </p:txBody>
+      </p:sp>
+      <p:sp>
+        <p:nvSpPr>
+          <p:cNvPr id="15" name="TextBox 14"/>
+          <p:cNvSpPr txBox="1"/>
+          <p:nvPr/>
+        </p:nvSpPr>
+        <p:spPr>
+          <a:xfrm>
+            <a:off x="8833104" y="2057399"/>
+            <a:ext cx="2176272" cy="164592"/>
+          </a:xfrm>
+          <a:prstGeom prst="rect">
+            <a:avLst/>
+          </a:prstGeom>
+          <a:noFill/>
+        </p:spPr>
+        <p:txBody>
+          <a:bodyPr wrap="none" lIns="0" rIns="0" tIns="0" bIns="0">
+            <a:spAutoFit/>
+          </a:bodyPr>
+          <a:lstStyle/>
+          <a:p>
+            <a:pPr algn="l"/>
+            <a:r>
+              <a:rPr sz="1000" b="1">
+                <a:solidFill>
+                  <a:srgbClr val="FFFFFF"/>
+                </a:solidFill>
+                <a:latin typeface="Arial"/>
+              </a:rPr>
+              <a:t>Design focus</a:t>
+            </a:r>
+          </a:p>
+        </p:txBody>
+      </p:sp>
+      <p:sp>
+        <p:nvSpPr>
+          <p:cNvPr id="16" name="Rectangle 15"/>
+          <p:cNvSpPr/>
+          <p:nvPr/>
+        </p:nvSpPr>
+        <p:spPr>
+          <a:xfrm>
+            <a:off x="777240" y="2468879"/>
+            <a:ext cx="2286000" cy="822960"/>
+          </a:xfrm>
+          <a:prstGeom prst="rect">
             <a:avLst/>
           </a:prstGeom>
           <a:solidFill>
@@ -5297,7 +6140,7 @@
           </a:solidFill>
           <a:ln>
             <a:solidFill>
-              <a:srgbClr val="F6F9FC"/>
+              <a:srgbClr val="DDE7F0"/>
             </a:solidFill>
           </a:ln>
         </p:spPr>
@@ -5325,14 +6168,14 @@
       </p:sp>
       <p:sp>
         <p:nvSpPr>
-          <p:cNvPr id="7" name="TextBox 6"/>
+          <p:cNvPr id="17" name="TextBox 16"/>
           <p:cNvSpPr txBox="1"/>
           <p:nvPr/>
         </p:nvSpPr>
         <p:spPr>
           <a:xfrm>
-            <a:off x="969264" y="1572768"/>
-            <a:ext cx="2743200" cy="310896"/>
+            <a:off x="923544" y="2761487"/>
+            <a:ext cx="1993392" cy="182880"/>
           </a:xfrm>
           <a:prstGeom prst="rect">
             <a:avLst/>
@@ -5345,9 +6188,9 @@
           </a:bodyPr>
           <a:lstStyle/>
           <a:p>
-            <a:pPr algn="ctr"/>
-            <a:r>
-              <a:rPr sz="2100" b="1">
+            <a:pPr algn="l"/>
+            <a:r>
+              <a:rPr sz="1100" b="1">
                 <a:solidFill>
                   <a:srgbClr val="0097D6"/>
                 </a:solidFill>
@@ -5358,50 +6201,26 @@
           </a:p>
         </p:txBody>
       </p:sp>
-      <p:pic>
-        <p:nvPicPr>
-          <p:cNvPr id="8" name="Picture 7" descr="classic_card.png"/>
-          <p:cNvPicPr>
-            <a:picLocks noChangeAspect="1"/>
-          </p:cNvPicPr>
-          <p:nvPr/>
-        </p:nvPicPr>
-        <p:blipFill>
-          <a:blip r:embed="rId2"/>
-          <a:stretch>
-            <a:fillRect/>
-          </a:stretch>
-        </p:blipFill>
-        <p:spPr>
-          <a:xfrm>
-            <a:off x="877824" y="2071116"/>
-            <a:ext cx="2971800" cy="1965960"/>
-          </a:xfrm>
-          <a:prstGeom prst="rect">
-            <a:avLst/>
-          </a:prstGeom>
-        </p:spPr>
-      </p:pic>
-      <p:sp>
-        <p:nvSpPr>
-          <p:cNvPr id="9" name="Rounded Rectangle 8"/>
+      <p:sp>
+        <p:nvSpPr>
+          <p:cNvPr id="18" name="Rectangle 17"/>
           <p:cNvSpPr/>
           <p:nvPr/>
         </p:nvSpPr>
         <p:spPr>
           <a:xfrm>
-            <a:off x="1207008" y="4361688"/>
-            <a:ext cx="2331720" cy="502920"/>
-          </a:xfrm>
-          <a:prstGeom prst="roundRect">
+            <a:off x="3063240" y="2468879"/>
+            <a:ext cx="2743200" cy="822960"/>
+          </a:xfrm>
+          <a:prstGeom prst="rect">
             <a:avLst/>
           </a:prstGeom>
           <a:solidFill>
-            <a:srgbClr val="0097D6"/>
+            <a:srgbClr val="F6F9FC"/>
           </a:solidFill>
           <a:ln>
             <a:solidFill>
-              <a:srgbClr val="0097D6"/>
+              <a:srgbClr val="DDE7F0"/>
             </a:solidFill>
           </a:ln>
         </p:spPr>
@@ -5429,14 +6248,14 @@
       </p:sp>
       <p:sp>
         <p:nvSpPr>
-          <p:cNvPr id="10" name="TextBox 9"/>
+          <p:cNvPr id="19" name="TextBox 18"/>
           <p:cNvSpPr txBox="1"/>
           <p:nvPr/>
         </p:nvSpPr>
         <p:spPr>
           <a:xfrm>
-            <a:off x="1298448" y="4517136"/>
-            <a:ext cx="2148840" cy="182880"/>
+            <a:off x="3209544" y="2761487"/>
+            <a:ext cx="2450592" cy="182880"/>
           </a:xfrm>
           <a:prstGeom prst="rect">
             <a:avLst/>
@@ -5449,66 +6268,31 @@
           </a:bodyPr>
           <a:lstStyle/>
           <a:p>
-            <a:pPr algn="ctr"/>
-            <a:r>
-              <a:rPr sz="1000" b="1">
-                <a:solidFill>
-                  <a:srgbClr val="FFFFFF"/>
+            <a:pPr algn="l"/>
+            <a:r>
+              <a:rPr sz="1100" b="0">
+                <a:solidFill>
+                  <a:srgbClr val="1A2636"/>
                 </a:solidFill>
                 <a:latin typeface="Arial"/>
               </a:rPr>
-              <a:t>Everyday payments</a:t>
-            </a:r>
-          </a:p>
-        </p:txBody>
-      </p:sp>
-      <p:sp>
-        <p:nvSpPr>
-          <p:cNvPr id="11" name="TextBox 10"/>
-          <p:cNvSpPr txBox="1"/>
-          <p:nvPr/>
-        </p:nvSpPr>
-        <p:spPr>
-          <a:xfrm>
-            <a:off x="1060704" y="5138928"/>
-            <a:ext cx="2615184" cy="320040"/>
-          </a:xfrm>
-          <a:prstGeom prst="rect">
-            <a:avLst/>
-          </a:prstGeom>
-          <a:noFill/>
-        </p:spPr>
-        <p:txBody>
-          <a:bodyPr wrap="none" lIns="0" rIns="0" tIns="0" bIns="0">
-            <a:spAutoFit/>
-          </a:bodyPr>
-          <a:lstStyle/>
-          <a:p>
-            <a:pPr algn="ctr"/>
-            <a:r>
-              <a:rPr sz="1100" b="0">
-                <a:solidFill>
-                  <a:srgbClr val="5C6874"/>
-                </a:solidFill>
-                <a:latin typeface="Arial"/>
-              </a:rPr>
-              <a:t>Clear image, simple label, one message.</a:t>
-            </a:r>
-          </a:p>
-        </p:txBody>
-      </p:sp>
-      <p:sp>
-        <p:nvSpPr>
-          <p:cNvPr id="12" name="Rounded Rectangle 11"/>
+              <a:t>Classic blue</a:t>
+            </a:r>
+          </a:p>
+        </p:txBody>
+      </p:sp>
+      <p:sp>
+        <p:nvSpPr>
+          <p:cNvPr id="20" name="Rectangle 19"/>
           <p:cNvSpPr/>
           <p:nvPr/>
         </p:nvSpPr>
         <p:spPr>
           <a:xfrm>
-            <a:off x="4535424" y="1325880"/>
-            <a:ext cx="3310128" cy="4526280"/>
-          </a:xfrm>
-          <a:prstGeom prst="roundRect">
+            <a:off x="5806440" y="2468879"/>
+            <a:ext cx="2880360" cy="822960"/>
+          </a:xfrm>
+          <a:prstGeom prst="rect">
             <a:avLst/>
           </a:prstGeom>
           <a:solidFill>
@@ -5516,7 +6300,7 @@
           </a:solidFill>
           <a:ln>
             <a:solidFill>
-              <a:srgbClr val="F6F9FC"/>
+              <a:srgbClr val="DDE7F0"/>
             </a:solidFill>
           </a:ln>
         </p:spPr>
@@ -5544,14 +6328,14 @@
       </p:sp>
       <p:sp>
         <p:nvSpPr>
-          <p:cNvPr id="13" name="TextBox 12"/>
+          <p:cNvPr id="21" name="TextBox 20"/>
           <p:cNvSpPr txBox="1"/>
           <p:nvPr/>
         </p:nvSpPr>
         <p:spPr>
           <a:xfrm>
-            <a:off x="4791456" y="1572768"/>
-            <a:ext cx="2743200" cy="310896"/>
+            <a:off x="5952744" y="2761487"/>
+            <a:ext cx="2587752" cy="182880"/>
           </a:xfrm>
           <a:prstGeom prst="rect">
             <a:avLst/>
@@ -5564,63 +6348,39 @@
           </a:bodyPr>
           <a:lstStyle/>
           <a:p>
-            <a:pPr algn="ctr"/>
-            <a:r>
-              <a:rPr sz="2100" b="1">
+            <a:pPr algn="l"/>
+            <a:r>
+              <a:rPr sz="1100" b="0">
                 <a:solidFill>
                   <a:srgbClr val="1A2636"/>
                 </a:solidFill>
                 <a:latin typeface="Arial"/>
               </a:rPr>
-              <a:t>Titanium</a:t>
-            </a:r>
-          </a:p>
-        </p:txBody>
-      </p:sp>
-      <p:pic>
-        <p:nvPicPr>
-          <p:cNvPr id="14" name="Picture 13" descr="titanium_card.png"/>
-          <p:cNvPicPr>
-            <a:picLocks noChangeAspect="1"/>
-          </p:cNvPicPr>
-          <p:nvPr/>
-        </p:nvPicPr>
-        <p:blipFill>
-          <a:blip r:embed="rId3"/>
-          <a:stretch>
-            <a:fillRect/>
-          </a:stretch>
-        </p:blipFill>
-        <p:spPr>
-          <a:xfrm>
-            <a:off x="4700016" y="2071116"/>
-            <a:ext cx="2971800" cy="1965960"/>
-          </a:xfrm>
-          <a:prstGeom prst="rect">
-            <a:avLst/>
-          </a:prstGeom>
-        </p:spPr>
-      </p:pic>
-      <p:sp>
-        <p:nvSpPr>
-          <p:cNvPr id="15" name="Rounded Rectangle 14"/>
+              <a:t>Everyday rewards</a:t>
+            </a:r>
+          </a:p>
+        </p:txBody>
+      </p:sp>
+      <p:sp>
+        <p:nvSpPr>
+          <p:cNvPr id="22" name="Rectangle 21"/>
           <p:cNvSpPr/>
           <p:nvPr/>
         </p:nvSpPr>
         <p:spPr>
           <a:xfrm>
-            <a:off x="5029200" y="4361688"/>
-            <a:ext cx="2331720" cy="502920"/>
-          </a:xfrm>
-          <a:prstGeom prst="roundRect">
+            <a:off x="8686800" y="2468879"/>
+            <a:ext cx="2468880" cy="822960"/>
+          </a:xfrm>
+          <a:prstGeom prst="rect">
             <a:avLst/>
           </a:prstGeom>
           <a:solidFill>
-            <a:srgbClr val="1A2636"/>
+            <a:srgbClr val="F6F9FC"/>
           </a:solidFill>
           <a:ln>
             <a:solidFill>
-              <a:srgbClr val="1A2636"/>
+              <a:srgbClr val="DDE7F0"/>
             </a:solidFill>
           </a:ln>
         </p:spPr>
@@ -5648,14 +6408,14 @@
       </p:sp>
       <p:sp>
         <p:nvSpPr>
-          <p:cNvPr id="16" name="TextBox 15"/>
+          <p:cNvPr id="23" name="TextBox 22"/>
           <p:cNvSpPr txBox="1"/>
           <p:nvPr/>
         </p:nvSpPr>
         <p:spPr>
           <a:xfrm>
-            <a:off x="5120640" y="4517136"/>
-            <a:ext cx="2148840" cy="182880"/>
+            <a:off x="8833104" y="2761487"/>
+            <a:ext cx="2176272" cy="182880"/>
           </a:xfrm>
           <a:prstGeom prst="rect">
             <a:avLst/>
@@ -5668,29 +6428,74 @@
           </a:bodyPr>
           <a:lstStyle/>
           <a:p>
-            <a:pPr algn="ctr"/>
-            <a:r>
-              <a:rPr sz="1000" b="1">
-                <a:solidFill>
-                  <a:srgbClr val="FFFFFF"/>
+            <a:pPr algn="l"/>
+            <a:r>
+              <a:rPr sz="1100" b="0">
+                <a:solidFill>
+                  <a:srgbClr val="1A2636"/>
                 </a:solidFill>
                 <a:latin typeface="Arial"/>
               </a:rPr>
-              <a:t>Higher-tier daily card</a:t>
-            </a:r>
-          </a:p>
-        </p:txBody>
-      </p:sp>
-      <p:sp>
-        <p:nvSpPr>
-          <p:cNvPr id="17" name="TextBox 16"/>
+              <a:t>Simple card-first layout</a:t>
+            </a:r>
+          </a:p>
+        </p:txBody>
+      </p:sp>
+      <p:sp>
+        <p:nvSpPr>
+          <p:cNvPr id="24" name="Rectangle 23"/>
+          <p:cNvSpPr/>
+          <p:nvPr/>
+        </p:nvSpPr>
+        <p:spPr>
+          <a:xfrm>
+            <a:off x="777240" y="3291839"/>
+            <a:ext cx="2286000" cy="822960"/>
+          </a:xfrm>
+          <a:prstGeom prst="rect">
+            <a:avLst/>
+          </a:prstGeom>
+          <a:solidFill>
+            <a:srgbClr val="FFFFFF"/>
+          </a:solidFill>
+          <a:ln>
+            <a:solidFill>
+              <a:srgbClr val="DDE7F0"/>
+            </a:solidFill>
+          </a:ln>
+        </p:spPr>
+        <p:style>
+          <a:lnRef idx="1">
+            <a:schemeClr val="accent1"/>
+          </a:lnRef>
+          <a:fillRef idx="3">
+            <a:schemeClr val="accent1"/>
+          </a:fillRef>
+          <a:effectRef idx="2">
+            <a:schemeClr val="accent1"/>
+          </a:effectRef>
+          <a:fontRef idx="minor">
+            <a:schemeClr val="lt1"/>
+          </a:fontRef>
+        </p:style>
+        <p:txBody>
+          <a:bodyPr rtlCol="0" anchor="ctr"/>
+          <a:lstStyle/>
+          <a:p>
+            <a:pPr algn="ctr"/>
+          </a:p>
+        </p:txBody>
+      </p:sp>
+      <p:sp>
+        <p:nvSpPr>
+          <p:cNvPr id="25" name="TextBox 24"/>
           <p:cNvSpPr txBox="1"/>
           <p:nvPr/>
         </p:nvSpPr>
         <p:spPr>
           <a:xfrm>
-            <a:off x="4882896" y="5138928"/>
-            <a:ext cx="2615184" cy="320040"/>
+            <a:off x="923544" y="3584447"/>
+            <a:ext cx="1993392" cy="182880"/>
           </a:xfrm>
           <a:prstGeom prst="rect">
             <a:avLst/>
@@ -5703,31 +6508,271 @@
           </a:bodyPr>
           <a:lstStyle/>
           <a:p>
-            <a:pPr algn="ctr"/>
-            <a:r>
-              <a:rPr sz="1100" b="0">
-                <a:solidFill>
-                  <a:srgbClr val="5C6874"/>
+            <a:pPr algn="l"/>
+            <a:r>
+              <a:rPr sz="1100" b="1">
+                <a:solidFill>
+                  <a:srgbClr val="1A2636"/>
                 </a:solidFill>
                 <a:latin typeface="Arial"/>
               </a:rPr>
-              <a:t>Clear image, simple label, one message.</a:t>
-            </a:r>
-          </a:p>
-        </p:txBody>
-      </p:sp>
-      <p:sp>
-        <p:nvSpPr>
-          <p:cNvPr id="18" name="Rounded Rectangle 17"/>
+              <a:t>Titanium</a:t>
+            </a:r>
+          </a:p>
+        </p:txBody>
+      </p:sp>
+      <p:sp>
+        <p:nvSpPr>
+          <p:cNvPr id="26" name="Rectangle 25"/>
           <p:cNvSpPr/>
           <p:nvPr/>
         </p:nvSpPr>
         <p:spPr>
           <a:xfrm>
-            <a:off x="8357615" y="1325880"/>
-            <a:ext cx="3310128" cy="4526280"/>
-          </a:xfrm>
-          <a:prstGeom prst="roundRect">
+            <a:off x="3063240" y="3291839"/>
+            <a:ext cx="2743200" cy="822960"/>
+          </a:xfrm>
+          <a:prstGeom prst="rect">
+            <a:avLst/>
+          </a:prstGeom>
+          <a:solidFill>
+            <a:srgbClr val="FFFFFF"/>
+          </a:solidFill>
+          <a:ln>
+            <a:solidFill>
+              <a:srgbClr val="DDE7F0"/>
+            </a:solidFill>
+          </a:ln>
+        </p:spPr>
+        <p:style>
+          <a:lnRef idx="1">
+            <a:schemeClr val="accent1"/>
+          </a:lnRef>
+          <a:fillRef idx="3">
+            <a:schemeClr val="accent1"/>
+          </a:fillRef>
+          <a:effectRef idx="2">
+            <a:schemeClr val="accent1"/>
+          </a:effectRef>
+          <a:fontRef idx="minor">
+            <a:schemeClr val="lt1"/>
+          </a:fontRef>
+        </p:style>
+        <p:txBody>
+          <a:bodyPr rtlCol="0" anchor="ctr"/>
+          <a:lstStyle/>
+          <a:p>
+            <a:pPr algn="ctr"/>
+          </a:p>
+        </p:txBody>
+      </p:sp>
+      <p:sp>
+        <p:nvSpPr>
+          <p:cNvPr id="27" name="TextBox 26"/>
+          <p:cNvSpPr txBox="1"/>
+          <p:nvPr/>
+        </p:nvSpPr>
+        <p:spPr>
+          <a:xfrm>
+            <a:off x="3209544" y="3584447"/>
+            <a:ext cx="2450592" cy="182880"/>
+          </a:xfrm>
+          <a:prstGeom prst="rect">
+            <a:avLst/>
+          </a:prstGeom>
+          <a:noFill/>
+        </p:spPr>
+        <p:txBody>
+          <a:bodyPr wrap="none" lIns="0" rIns="0" tIns="0" bIns="0">
+            <a:spAutoFit/>
+          </a:bodyPr>
+          <a:lstStyle/>
+          <a:p>
+            <a:pPr algn="l"/>
+            <a:r>
+              <a:rPr sz="1100" b="0">
+                <a:solidFill>
+                  <a:srgbClr val="1A2636"/>
+                </a:solidFill>
+                <a:latin typeface="Arial"/>
+              </a:rPr>
+              <a:t>Dark titanium</a:t>
+            </a:r>
+          </a:p>
+        </p:txBody>
+      </p:sp>
+      <p:sp>
+        <p:nvSpPr>
+          <p:cNvPr id="28" name="Rectangle 27"/>
+          <p:cNvSpPr/>
+          <p:nvPr/>
+        </p:nvSpPr>
+        <p:spPr>
+          <a:xfrm>
+            <a:off x="5806440" y="3291839"/>
+            <a:ext cx="2880360" cy="822960"/>
+          </a:xfrm>
+          <a:prstGeom prst="rect">
+            <a:avLst/>
+          </a:prstGeom>
+          <a:solidFill>
+            <a:srgbClr val="FFFFFF"/>
+          </a:solidFill>
+          <a:ln>
+            <a:solidFill>
+              <a:srgbClr val="DDE7F0"/>
+            </a:solidFill>
+          </a:ln>
+        </p:spPr>
+        <p:style>
+          <a:lnRef idx="1">
+            <a:schemeClr val="accent1"/>
+          </a:lnRef>
+          <a:fillRef idx="3">
+            <a:schemeClr val="accent1"/>
+          </a:fillRef>
+          <a:effectRef idx="2">
+            <a:schemeClr val="accent1"/>
+          </a:effectRef>
+          <a:fontRef idx="minor">
+            <a:schemeClr val="lt1"/>
+          </a:fontRef>
+        </p:style>
+        <p:txBody>
+          <a:bodyPr rtlCol="0" anchor="ctr"/>
+          <a:lstStyle/>
+          <a:p>
+            <a:pPr algn="ctr"/>
+          </a:p>
+        </p:txBody>
+      </p:sp>
+      <p:sp>
+        <p:nvSpPr>
+          <p:cNvPr id="29" name="TextBox 28"/>
+          <p:cNvSpPr txBox="1"/>
+          <p:nvPr/>
+        </p:nvSpPr>
+        <p:spPr>
+          <a:xfrm>
+            <a:off x="5952744" y="3584447"/>
+            <a:ext cx="2587752" cy="182880"/>
+          </a:xfrm>
+          <a:prstGeom prst="rect">
+            <a:avLst/>
+          </a:prstGeom>
+          <a:noFill/>
+        </p:spPr>
+        <p:txBody>
+          <a:bodyPr wrap="none" lIns="0" rIns="0" tIns="0" bIns="0">
+            <a:spAutoFit/>
+          </a:bodyPr>
+          <a:lstStyle/>
+          <a:p>
+            <a:pPr algn="l"/>
+            <a:r>
+              <a:rPr sz="1100" b="0">
+                <a:solidFill>
+                  <a:srgbClr val="1A2636"/>
+                </a:solidFill>
+                <a:latin typeface="Arial"/>
+              </a:rPr>
+              <a:t>Daily premium feel</a:t>
+            </a:r>
+          </a:p>
+        </p:txBody>
+      </p:sp>
+      <p:sp>
+        <p:nvSpPr>
+          <p:cNvPr id="30" name="Rectangle 29"/>
+          <p:cNvSpPr/>
+          <p:nvPr/>
+        </p:nvSpPr>
+        <p:spPr>
+          <a:xfrm>
+            <a:off x="8686800" y="3291839"/>
+            <a:ext cx="2468880" cy="822960"/>
+          </a:xfrm>
+          <a:prstGeom prst="rect">
+            <a:avLst/>
+          </a:prstGeom>
+          <a:solidFill>
+            <a:srgbClr val="FFFFFF"/>
+          </a:solidFill>
+          <a:ln>
+            <a:solidFill>
+              <a:srgbClr val="DDE7F0"/>
+            </a:solidFill>
+          </a:ln>
+        </p:spPr>
+        <p:style>
+          <a:lnRef idx="1">
+            <a:schemeClr val="accent1"/>
+          </a:lnRef>
+          <a:fillRef idx="3">
+            <a:schemeClr val="accent1"/>
+          </a:fillRef>
+          <a:effectRef idx="2">
+            <a:schemeClr val="accent1"/>
+          </a:effectRef>
+          <a:fontRef idx="minor">
+            <a:schemeClr val="lt1"/>
+          </a:fontRef>
+        </p:style>
+        <p:txBody>
+          <a:bodyPr rtlCol="0" anchor="ctr"/>
+          <a:lstStyle/>
+          <a:p>
+            <a:pPr algn="ctr"/>
+          </a:p>
+        </p:txBody>
+      </p:sp>
+      <p:sp>
+        <p:nvSpPr>
+          <p:cNvPr id="31" name="TextBox 30"/>
+          <p:cNvSpPr txBox="1"/>
+          <p:nvPr/>
+        </p:nvSpPr>
+        <p:spPr>
+          <a:xfrm>
+            <a:off x="8833104" y="3584447"/>
+            <a:ext cx="2176272" cy="182880"/>
+          </a:xfrm>
+          <a:prstGeom prst="rect">
+            <a:avLst/>
+          </a:prstGeom>
+          <a:noFill/>
+        </p:spPr>
+        <p:txBody>
+          <a:bodyPr wrap="none" lIns="0" rIns="0" tIns="0" bIns="0">
+            <a:spAutoFit/>
+          </a:bodyPr>
+          <a:lstStyle/>
+          <a:p>
+            <a:pPr algn="l"/>
+            <a:r>
+              <a:rPr sz="1100" b="0">
+                <a:solidFill>
+                  <a:srgbClr val="1A2636"/>
+                </a:solidFill>
+                <a:latin typeface="Arial"/>
+              </a:rPr>
+              <a:t>Simple card-first layout</a:t>
+            </a:r>
+          </a:p>
+        </p:txBody>
+      </p:sp>
+      <p:sp>
+        <p:nvSpPr>
+          <p:cNvPr id="32" name="Rectangle 31"/>
+          <p:cNvSpPr/>
+          <p:nvPr/>
+        </p:nvSpPr>
+        <p:spPr>
+          <a:xfrm>
+            <a:off x="777240" y="4114799"/>
+            <a:ext cx="2286000" cy="822960"/>
+          </a:xfrm>
+          <a:prstGeom prst="rect">
             <a:avLst/>
           </a:prstGeom>
           <a:solidFill>
@@ -5735,7 +6780,7 @@
           </a:solidFill>
           <a:ln>
             <a:solidFill>
-              <a:srgbClr val="F6F9FC"/>
+              <a:srgbClr val="DDE7F0"/>
             </a:solidFill>
           </a:ln>
         </p:spPr>
@@ -5763,14 +6808,14 @@
       </p:sp>
       <p:sp>
         <p:nvSpPr>
-          <p:cNvPr id="19" name="TextBox 18"/>
+          <p:cNvPr id="33" name="TextBox 32"/>
           <p:cNvSpPr txBox="1"/>
           <p:nvPr/>
         </p:nvSpPr>
         <p:spPr>
           <a:xfrm>
-            <a:off x="8613647" y="1572768"/>
-            <a:ext cx="2743200" cy="310896"/>
+            <a:off x="923544" y="4407407"/>
+            <a:ext cx="1993392" cy="182880"/>
           </a:xfrm>
           <a:prstGeom prst="rect">
             <a:avLst/>
@@ -5783,9 +6828,9 @@
           </a:bodyPr>
           <a:lstStyle/>
           <a:p>
-            <a:pPr algn="ctr"/>
-            <a:r>
-              <a:rPr sz="2100" b="1">
+            <a:pPr algn="l"/>
+            <a:r>
+              <a:rPr sz="1100" b="1">
                 <a:solidFill>
                   <a:srgbClr val="F2A630"/>
                 </a:solidFill>
@@ -5796,50 +6841,26 @@
           </a:p>
         </p:txBody>
       </p:sp>
-      <p:pic>
-        <p:nvPicPr>
-          <p:cNvPr id="20" name="Picture 19" descr="platinum_card.png"/>
-          <p:cNvPicPr>
-            <a:picLocks noChangeAspect="1"/>
-          </p:cNvPicPr>
-          <p:nvPr/>
-        </p:nvPicPr>
-        <p:blipFill>
-          <a:blip r:embed="rId4"/>
-          <a:stretch>
-            <a:fillRect/>
-          </a:stretch>
-        </p:blipFill>
-        <p:spPr>
-          <a:xfrm>
-            <a:off x="8522207" y="2071116"/>
-            <a:ext cx="2971800" cy="1965960"/>
-          </a:xfrm>
-          <a:prstGeom prst="rect">
-            <a:avLst/>
-          </a:prstGeom>
-        </p:spPr>
-      </p:pic>
-      <p:sp>
-        <p:nvSpPr>
-          <p:cNvPr id="21" name="Rounded Rectangle 20"/>
+      <p:sp>
+        <p:nvSpPr>
+          <p:cNvPr id="34" name="Rectangle 33"/>
           <p:cNvSpPr/>
           <p:nvPr/>
         </p:nvSpPr>
         <p:spPr>
           <a:xfrm>
-            <a:off x="8851391" y="4361688"/>
-            <a:ext cx="2331720" cy="502920"/>
-          </a:xfrm>
-          <a:prstGeom prst="roundRect">
+            <a:off x="3063240" y="4114799"/>
+            <a:ext cx="2743200" cy="822960"/>
+          </a:xfrm>
+          <a:prstGeom prst="rect">
             <a:avLst/>
           </a:prstGeom>
           <a:solidFill>
-            <a:srgbClr val="F2A630"/>
+            <a:srgbClr val="F6F9FC"/>
           </a:solidFill>
           <a:ln>
             <a:solidFill>
-              <a:srgbClr val="F2A630"/>
+              <a:srgbClr val="DDE7F0"/>
             </a:solidFill>
           </a:ln>
         </p:spPr>
@@ -5867,14 +6888,14 @@
       </p:sp>
       <p:sp>
         <p:nvSpPr>
-          <p:cNvPr id="22" name="TextBox 21"/>
+          <p:cNvPr id="35" name="TextBox 34"/>
           <p:cNvSpPr txBox="1"/>
           <p:nvPr/>
         </p:nvSpPr>
         <p:spPr>
           <a:xfrm>
-            <a:off x="8942831" y="4517136"/>
-            <a:ext cx="2148840" cy="182880"/>
+            <a:off x="3209544" y="4407407"/>
+            <a:ext cx="2450592" cy="182880"/>
           </a:xfrm>
           <a:prstGeom prst="rect">
             <a:avLst/>
@@ -5887,11 +6908,91 @@
           </a:bodyPr>
           <a:lstStyle/>
           <a:p>
+            <a:pPr algn="l"/>
+            <a:r>
+              <a:rPr sz="1100" b="0">
+                <a:solidFill>
+                  <a:srgbClr val="1A2636"/>
+                </a:solidFill>
+                <a:latin typeface="Arial"/>
+              </a:rPr>
+              <a:t>Silver premium</a:t>
+            </a:r>
+          </a:p>
+        </p:txBody>
+      </p:sp>
+      <p:sp>
+        <p:nvSpPr>
+          <p:cNvPr id="36" name="Rectangle 35"/>
+          <p:cNvSpPr/>
+          <p:nvPr/>
+        </p:nvSpPr>
+        <p:spPr>
+          <a:xfrm>
+            <a:off x="5806440" y="4114799"/>
+            <a:ext cx="2880360" cy="822960"/>
+          </a:xfrm>
+          <a:prstGeom prst="rect">
+            <a:avLst/>
+          </a:prstGeom>
+          <a:solidFill>
+            <a:srgbClr val="F6F9FC"/>
+          </a:solidFill>
+          <a:ln>
+            <a:solidFill>
+              <a:srgbClr val="DDE7F0"/>
+            </a:solidFill>
+          </a:ln>
+        </p:spPr>
+        <p:style>
+          <a:lnRef idx="1">
+            <a:schemeClr val="accent1"/>
+          </a:lnRef>
+          <a:fillRef idx="3">
+            <a:schemeClr val="accent1"/>
+          </a:fillRef>
+          <a:effectRef idx="2">
+            <a:schemeClr val="accent1"/>
+          </a:effectRef>
+          <a:fontRef idx="minor">
+            <a:schemeClr val="lt1"/>
+          </a:fontRef>
+        </p:style>
+        <p:txBody>
+          <a:bodyPr rtlCol="0" anchor="ctr"/>
+          <a:lstStyle/>
+          <a:p>
             <a:pPr algn="ctr"/>
-            <a:r>
-              <a:rPr sz="1000" b="1">
-                <a:solidFill>
-                  <a:srgbClr val="FFFFFF"/>
+          </a:p>
+        </p:txBody>
+      </p:sp>
+      <p:sp>
+        <p:nvSpPr>
+          <p:cNvPr id="37" name="TextBox 36"/>
+          <p:cNvSpPr txBox="1"/>
+          <p:nvPr/>
+        </p:nvSpPr>
+        <p:spPr>
+          <a:xfrm>
+            <a:off x="5952744" y="4407407"/>
+            <a:ext cx="2587752" cy="182880"/>
+          </a:xfrm>
+          <a:prstGeom prst="rect">
+            <a:avLst/>
+          </a:prstGeom>
+          <a:noFill/>
+        </p:spPr>
+        <p:txBody>
+          <a:bodyPr wrap="none" lIns="0" rIns="0" tIns="0" bIns="0">
+            <a:spAutoFit/>
+          </a:bodyPr>
+          <a:lstStyle/>
+          <a:p>
+            <a:pPr algn="l"/>
+            <a:r>
+              <a:rPr sz="1100" b="0">
+                <a:solidFill>
+                  <a:srgbClr val="1A2636"/>
                 </a:solidFill>
                 <a:latin typeface="Arial"/>
               </a:rPr>
@@ -5902,14 +7003,59 @@
       </p:sp>
       <p:sp>
         <p:nvSpPr>
-          <p:cNvPr id="23" name="TextBox 22"/>
+          <p:cNvPr id="38" name="Rectangle 37"/>
+          <p:cNvSpPr/>
+          <p:nvPr/>
+        </p:nvSpPr>
+        <p:spPr>
+          <a:xfrm>
+            <a:off x="8686800" y="4114799"/>
+            <a:ext cx="2468880" cy="822960"/>
+          </a:xfrm>
+          <a:prstGeom prst="rect">
+            <a:avLst/>
+          </a:prstGeom>
+          <a:solidFill>
+            <a:srgbClr val="F6F9FC"/>
+          </a:solidFill>
+          <a:ln>
+            <a:solidFill>
+              <a:srgbClr val="DDE7F0"/>
+            </a:solidFill>
+          </a:ln>
+        </p:spPr>
+        <p:style>
+          <a:lnRef idx="1">
+            <a:schemeClr val="accent1"/>
+          </a:lnRef>
+          <a:fillRef idx="3">
+            <a:schemeClr val="accent1"/>
+          </a:fillRef>
+          <a:effectRef idx="2">
+            <a:schemeClr val="accent1"/>
+          </a:effectRef>
+          <a:fontRef idx="minor">
+            <a:schemeClr val="lt1"/>
+          </a:fontRef>
+        </p:style>
+        <p:txBody>
+          <a:bodyPr rtlCol="0" anchor="ctr"/>
+          <a:lstStyle/>
+          <a:p>
+            <a:pPr algn="ctr"/>
+          </a:p>
+        </p:txBody>
+      </p:sp>
+      <p:sp>
+        <p:nvSpPr>
+          <p:cNvPr id="39" name="TextBox 38"/>
           <p:cNvSpPr txBox="1"/>
           <p:nvPr/>
         </p:nvSpPr>
         <p:spPr>
           <a:xfrm>
-            <a:off x="8705087" y="5138928"/>
-            <a:ext cx="2615184" cy="320040"/>
+            <a:off x="8833104" y="4407407"/>
+            <a:ext cx="2176272" cy="182880"/>
           </a:xfrm>
           <a:prstGeom prst="rect">
             <a:avLst/>
@@ -5922,15 +7068,165 @@
           </a:bodyPr>
           <a:lstStyle/>
           <a:p>
-            <a:pPr algn="ctr"/>
+            <a:pPr algn="l"/>
             <a:r>
               <a:rPr sz="1100" b="0">
                 <a:solidFill>
-                  <a:srgbClr val="5C6874"/>
+                  <a:srgbClr val="1A2636"/>
                 </a:solidFill>
                 <a:latin typeface="Arial"/>
               </a:rPr>
-              <a:t>Clear image, simple label, one message.</a:t>
+              <a:t>Simple card-first layout</a:t>
+            </a:r>
+          </a:p>
+        </p:txBody>
+      </p:sp>
+      <p:sp>
+        <p:nvSpPr>
+          <p:cNvPr id="40" name="TextBox 39"/>
+          <p:cNvSpPr txBox="1"/>
+          <p:nvPr/>
+        </p:nvSpPr>
+        <p:spPr>
+          <a:xfrm>
+            <a:off x="1051560" y="5285232"/>
+            <a:ext cx="10012680" cy="320040"/>
+          </a:xfrm>
+          <a:prstGeom prst="rect">
+            <a:avLst/>
+          </a:prstGeom>
+          <a:noFill/>
+        </p:spPr>
+        <p:txBody>
+          <a:bodyPr wrap="none" lIns="0" rIns="0" tIns="0" bIns="0">
+            <a:spAutoFit/>
+          </a:bodyPr>
+          <a:lstStyle/>
+          <a:p>
+            <a:pPr algn="ctr"/>
+            <a:r>
+              <a:rPr sz="1400" b="0">
+                <a:solidFill>
+                  <a:srgbClr val="5C6874"/>
+                </a:solidFill>
+                <a:latin typeface="Arial"/>
+              </a:rPr>
+              <a:t>Recommendation: keep each slide focused on one product, one image, and three short messages.</a:t>
+            </a:r>
+          </a:p>
+        </p:txBody>
+      </p:sp>
+      <p:sp>
+        <p:nvSpPr>
+          <p:cNvPr id="41" name="Rectangle 40"/>
+          <p:cNvSpPr/>
+          <p:nvPr/>
+        </p:nvSpPr>
+        <p:spPr>
+          <a:xfrm>
+            <a:off x="658368" y="6291072"/>
+            <a:ext cx="10881360" cy="9144"/>
+          </a:xfrm>
+          <a:prstGeom prst="rect">
+            <a:avLst/>
+          </a:prstGeom>
+          <a:solidFill>
+            <a:srgbClr val="DDE7F0"/>
+          </a:solidFill>
+          <a:ln>
+            <a:solidFill>
+              <a:srgbClr val="DDE7F0"/>
+            </a:solidFill>
+          </a:ln>
+        </p:spPr>
+        <p:style>
+          <a:lnRef idx="1">
+            <a:schemeClr val="accent1"/>
+          </a:lnRef>
+          <a:fillRef idx="3">
+            <a:schemeClr val="accent1"/>
+          </a:fillRef>
+          <a:effectRef idx="2">
+            <a:schemeClr val="accent1"/>
+          </a:effectRef>
+          <a:fontRef idx="minor">
+            <a:schemeClr val="lt1"/>
+          </a:fontRef>
+        </p:style>
+        <p:txBody>
+          <a:bodyPr rtlCol="0" anchor="ctr"/>
+          <a:lstStyle/>
+          <a:p>
+            <a:pPr algn="ctr"/>
+          </a:p>
+        </p:txBody>
+      </p:sp>
+      <p:sp>
+        <p:nvSpPr>
+          <p:cNvPr id="42" name="TextBox 41"/>
+          <p:cNvSpPr txBox="1"/>
+          <p:nvPr/>
+        </p:nvSpPr>
+        <p:spPr>
+          <a:xfrm>
+            <a:off x="658368" y="6428232"/>
+            <a:ext cx="2560320" cy="164592"/>
+          </a:xfrm>
+          <a:prstGeom prst="rect">
+            <a:avLst/>
+          </a:prstGeom>
+          <a:noFill/>
+        </p:spPr>
+        <p:txBody>
+          <a:bodyPr wrap="none" lIns="0" rIns="0" tIns="0" bIns="0">
+            <a:spAutoFit/>
+          </a:bodyPr>
+          <a:lstStyle/>
+          <a:p>
+            <a:pPr algn="l"/>
+            <a:r>
+              <a:rPr sz="900" b="0">
+                <a:solidFill>
+                  <a:srgbClr val="5C6874"/>
+                </a:solidFill>
+                <a:latin typeface="Arial"/>
+              </a:rPr>
+              <a:t>ADIB Cards Portfolio</a:t>
+            </a:r>
+          </a:p>
+        </p:txBody>
+      </p:sp>
+      <p:sp>
+        <p:nvSpPr>
+          <p:cNvPr id="43" name="TextBox 42"/>
+          <p:cNvSpPr txBox="1"/>
+          <p:nvPr/>
+        </p:nvSpPr>
+        <p:spPr>
+          <a:xfrm>
+            <a:off x="10927080" y="6428232"/>
+            <a:ext cx="594360" cy="164592"/>
+          </a:xfrm>
+          <a:prstGeom prst="rect">
+            <a:avLst/>
+          </a:prstGeom>
+          <a:noFill/>
+        </p:spPr>
+        <p:txBody>
+          <a:bodyPr wrap="none" lIns="0" rIns="0" tIns="0" bIns="0">
+            <a:spAutoFit/>
+          </a:bodyPr>
+          <a:lstStyle/>
+          <a:p>
+            <a:pPr algn="r"/>
+            <a:r>
+              <a:rPr sz="900" b="0">
+                <a:solidFill>
+                  <a:srgbClr val="5C6874"/>
+                </a:solidFill>
+                <a:latin typeface="Arial"/>
+              </a:rPr>
+              <a:t>05</a:t>
             </a:r>
           </a:p>
         </p:txBody>
@@ -5961,9 +7257,54 @@
         <p:nvPr/>
       </p:nvGrpSpPr>
       <p:grpSpPr/>
+      <p:sp>
+        <p:nvSpPr>
+          <p:cNvPr id="2" name="Rounded Rectangle 1"/>
+          <p:cNvSpPr/>
+          <p:nvPr/>
+        </p:nvSpPr>
+        <p:spPr>
+          <a:xfrm>
+            <a:off x="3154680" y="987552"/>
+            <a:ext cx="5897880" cy="4901184"/>
+          </a:xfrm>
+          <a:prstGeom prst="roundRect">
+            <a:avLst/>
+          </a:prstGeom>
+          <a:solidFill>
+            <a:srgbClr val="004D95"/>
+          </a:solidFill>
+          <a:ln>
+            <a:solidFill>
+              <a:srgbClr val="004D95"/>
+            </a:solidFill>
+          </a:ln>
+        </p:spPr>
+        <p:style>
+          <a:lnRef idx="1">
+            <a:schemeClr val="accent1"/>
+          </a:lnRef>
+          <a:fillRef idx="3">
+            <a:schemeClr val="accent1"/>
+          </a:fillRef>
+          <a:effectRef idx="2">
+            <a:schemeClr val="accent1"/>
+          </a:effectRef>
+          <a:fontRef idx="minor">
+            <a:schemeClr val="lt1"/>
+          </a:fontRef>
+        </p:style>
+        <p:txBody>
+          <a:bodyPr rtlCol="0" anchor="ctr"/>
+          <a:lstStyle/>
+          <a:p>
+            <a:pPr algn="ctr"/>
+          </a:p>
+        </p:txBody>
+      </p:sp>
       <p:pic>
         <p:nvPicPr>
-          <p:cNvPr id="2" name="Picture 1" descr="adib_logo_transparent.png"/>
+          <p:cNvPr id="3" name="Picture 2" descr="adib_logo_transparent.png"/>
           <p:cNvPicPr>
             <a:picLocks noChangeAspect="1"/>
           </p:cNvPicPr>
@@ -5977,8 +7318,8 @@
         </p:blipFill>
         <p:spPr>
           <a:xfrm>
-            <a:off x="5184648" y="1024128"/>
-            <a:ext cx="1325880" cy="1325880"/>
+            <a:off x="5358384" y="1536192"/>
+            <a:ext cx="1024128" cy="1024128"/>
           </a:xfrm>
           <a:prstGeom prst="rect">
             <a:avLst/>
@@ -5987,14 +7328,14 @@
       </p:pic>
       <p:sp>
         <p:nvSpPr>
-          <p:cNvPr id="3" name="TextBox 2"/>
+          <p:cNvPr id="4" name="TextBox 3"/>
           <p:cNvSpPr txBox="1"/>
           <p:nvPr/>
         </p:nvSpPr>
         <p:spPr>
           <a:xfrm>
-            <a:off x="4389120" y="2468880"/>
-            <a:ext cx="2926080" cy="502920"/>
+            <a:off x="4434840" y="2761488"/>
+            <a:ext cx="3337560" cy="457200"/>
           </a:xfrm>
           <a:prstGeom prst="rect">
             <a:avLst/>
@@ -6009,7 +7350,7 @@
           <a:p>
             <a:pPr algn="ctr"/>
             <a:r>
-              <a:rPr sz="4000" b="1">
+              <a:rPr sz="3600" b="1">
                 <a:solidFill>
                   <a:srgbClr val="FFFFFF"/>
                 </a:solidFill>
@@ -6022,14 +7363,14 @@
       </p:sp>
       <p:sp>
         <p:nvSpPr>
-          <p:cNvPr id="4" name="TextBox 3"/>
+          <p:cNvPr id="5" name="TextBox 4"/>
           <p:cNvSpPr txBox="1"/>
           <p:nvPr/>
         </p:nvSpPr>
         <p:spPr>
           <a:xfrm>
-            <a:off x="4160520" y="3054096"/>
-            <a:ext cx="3383280" cy="347472"/>
+            <a:off x="4343400" y="3346704"/>
+            <a:ext cx="3493008" cy="292608"/>
           </a:xfrm>
           <a:prstGeom prst="rect">
             <a:avLst/>
@@ -6044,9 +7385,9 @@
           <a:p>
             <a:pPr algn="ctr"/>
             <a:r>
-              <a:rPr sz="1900" b="1">
-                <a:solidFill>
-                  <a:srgbClr val="C2E6F7"/>
+              <a:rPr sz="1700" b="1">
+                <a:solidFill>
+                  <a:srgbClr val="C4E6F7"/>
                 </a:solidFill>
                 <a:latin typeface="Arial"/>
               </a:rPr>
@@ -6057,14 +7398,14 @@
       </p:sp>
       <p:sp>
         <p:nvSpPr>
-          <p:cNvPr id="5" name="TextBox 4"/>
+          <p:cNvPr id="6" name="TextBox 5"/>
           <p:cNvSpPr txBox="1"/>
           <p:nvPr/>
         </p:nvSpPr>
         <p:spPr>
           <a:xfrm>
-            <a:off x="3611880" y="3986784"/>
-            <a:ext cx="4480560" cy="457200"/>
+            <a:off x="3611880" y="4160520"/>
+            <a:ext cx="4983480" cy="384048"/>
           </a:xfrm>
           <a:prstGeom prst="rect">
             <a:avLst/>
@@ -6079,48 +7420,13 @@
           <a:p>
             <a:pPr algn="ctr"/>
             <a:r>
-              <a:rPr sz="2500" b="1">
+              <a:rPr sz="2400" b="1">
                 <a:solidFill>
                   <a:srgbClr val="FFFFFF"/>
                 </a:solidFill>
                 <a:latin typeface="Arial"/>
               </a:rPr>
-              <a:t>Simple. Secure. Rewarding.</a:t>
-            </a:r>
-          </a:p>
-        </p:txBody>
-      </p:sp>
-      <p:sp>
-        <p:nvSpPr>
-          <p:cNvPr id="6" name="TextBox 5"/>
-          <p:cNvSpPr txBox="1"/>
-          <p:nvPr/>
-        </p:nvSpPr>
-        <p:spPr>
-          <a:xfrm>
-            <a:off x="4892040" y="4773168"/>
-            <a:ext cx="2011680" cy="292608"/>
-          </a:xfrm>
-          <a:prstGeom prst="rect">
-            <a:avLst/>
-          </a:prstGeom>
-          <a:noFill/>
-        </p:spPr>
-        <p:txBody>
-          <a:bodyPr wrap="none" lIns="0" rIns="0" tIns="0" bIns="0">
-            <a:spAutoFit/>
-          </a:bodyPr>
-          <a:lstStyle/>
-          <a:p>
-            <a:pPr algn="ctr"/>
-            <a:r>
-              <a:rPr sz="1600" b="0">
-                <a:solidFill>
-                  <a:srgbClr val="C2E6F7"/>
-                </a:solidFill>
-                <a:latin typeface="Arial"/>
-              </a:rPr>
-              <a:t>Thank you</a:t>
+              <a:t>Simple. Professional. Visual.</a:t>
             </a:r>
           </a:p>
         </p:txBody>

</xml_diff>